<commit_message>
Add architecture/GCP infra diagrams, remove AI mentions, update repo links
</commit_message>
<xml_diff>
--- a/TechPapy_Presentation.pptx
+++ b/TechPapy_Presentation.pptx
@@ -14,10 +14,10 @@
     <p:sldId id="262" r:id="rId13"/>
     <p:sldId id="263" r:id="rId14"/>
     <p:sldId id="264" r:id="rId15"/>
+    <p:sldId id="270" r:id="rId21"/>
     <p:sldId id="265" r:id="rId16"/>
     <p:sldId id="266" r:id="rId17"/>
     <p:sldId id="267" r:id="rId18"/>
-    <p:sldId id="268" r:id="rId19"/>
     <p:sldId id="269" r:id="rId20"/>
   </p:sldIdLst>
   <p:sldSz cx="12191695" cy="6858000" type="screen4x3"/>
@@ -3524,7 +3524,7 @@
         <p:spPr>
           <a:xfrm>
             <a:off x="548640" y="457200"/>
-            <a:ext cx="1143000" cy="310896"/>
+            <a:ext cx="3200400" cy="310896"/>
           </a:xfrm>
           <a:prstGeom prst="rect">
             <a:avLst/>
@@ -3552,21 +3552,10 @@
           </a:fontRef>
         </p:style>
         <p:txBody>
-          <a:bodyPr rtlCol="0" anchor="ctr" wrap="none" lIns="109728" rIns="109728" tIns="18288" bIns="18288">
-            <a:noAutofit/>
-          </a:bodyPr>
+          <a:bodyPr rtlCol="0" anchor="ctr"/>
           <a:lstStyle/>
           <a:p>
             <a:pPr algn="ctr"/>
-            <a:r>
-              <a:rPr sz="1200" b="1">
-                <a:solidFill>
-                  <a:srgbClr val="111318"/>
-                </a:solidFill>
-                <a:latin typeface="Arial"/>
-              </a:rPr>
-              <a:t>STACK</a:t>
-            </a:r>
           </a:p>
         </p:txBody>
       </p:sp>
@@ -3578,6 +3567,40 @@
         </p:nvSpPr>
         <p:spPr>
           <a:xfrm>
+            <a:off x="548640" y="457200"/>
+            <a:ext cx="3200400" cy="310896"/>
+          </a:xfrm>
+          <a:prstGeom prst="rect">
+            <a:avLst/>
+          </a:prstGeom>
+          <a:noFill/>
+        </p:spPr>
+        <p:txBody>
+          <a:bodyPr wrap="square">
+            <a:spAutoFit/>
+          </a:bodyPr>
+          <a:lstStyle/>
+          <a:p>
+            <a:pPr algn="ctr"/>
+            <a:r>
+              <a:rPr sz="1300" b="1">
+                <a:solidFill>
+                  <a:srgbClr val="111318"/>
+                </a:solidFill>
+              </a:rPr>
+              <a:t>INFRASTRUCTURE</a:t>
+            </a:r>
+          </a:p>
+        </p:txBody>
+      </p:sp>
+      <p:sp>
+        <p:nvSpPr>
+          <p:cNvPr id="5" name="TextBox 4"/>
+          <p:cNvSpPr txBox="1"/>
+          <p:nvPr/>
+        </p:nvSpPr>
+        <p:spPr>
+          <a:xfrm>
             <a:off x="530352" y="868680"/>
             <a:ext cx="10789920" cy="822960"/>
           </a:xfrm>
@@ -3587,31 +3610,26 @@
           <a:noFill/>
         </p:spPr>
         <p:txBody>
-          <a:bodyPr wrap="square" anchor="t">
-            <a:noAutofit/>
-          </a:bodyPr>
-          <a:lstStyle/>
-          <a:p>
-            <a:pPr algn="l">
-              <a:lnSpc>
-                <a:spcPct val="100000"/>
-              </a:lnSpc>
-            </a:pPr>
-            <a:r>
-              <a:rPr sz="3000" b="1">
+          <a:bodyPr wrap="square">
+            <a:spAutoFit/>
+          </a:bodyPr>
+          <a:lstStyle/>
+          <a:p>
+            <a:pPr algn="l"/>
+            <a:r>
+              <a:rPr sz="2800" b="1">
                 <a:solidFill>
                   <a:srgbClr val="111318"/>
                 </a:solidFill>
-                <a:latin typeface="Arial"/>
-              </a:rPr>
-              <a:t>STACK TECHNIQUE</a:t>
-            </a:r>
-          </a:p>
-        </p:txBody>
-      </p:sp>
-      <p:sp>
-        <p:nvSpPr>
-          <p:cNvPr id="5" name="Rectangle 4"/>
+              </a:rPr>
+              <a:t>DÉPLOIEMENT SUR GOOGLE CLOUD</a:t>
+            </a:r>
+          </a:p>
+        </p:txBody>
+      </p:sp>
+      <p:sp>
+        <p:nvSpPr>
+          <p:cNvPr id="6" name="Rectangle 5"/>
           <p:cNvSpPr/>
           <p:nvPr/>
         </p:nvSpPr>
@@ -3619,128 +3637,6 @@
           <a:xfrm>
             <a:off x="548640" y="1536192"/>
             <a:ext cx="11064240" cy="19050"/>
-          </a:xfrm>
-          <a:prstGeom prst="rect">
-            <a:avLst/>
-          </a:prstGeom>
-          <a:solidFill>
-            <a:srgbClr val="111318"/>
-          </a:solidFill>
-          <a:ln>
-            <a:noFill/>
-          </a:ln>
-          <a:effectLst/>
-        </p:spPr>
-        <p:style>
-          <a:lnRef idx="1">
-            <a:schemeClr val="accent1"/>
-          </a:lnRef>
-          <a:fillRef idx="3">
-            <a:schemeClr val="accent1"/>
-          </a:fillRef>
-          <a:effectRef idx="2">
-            <a:schemeClr val="accent1"/>
-          </a:effectRef>
-          <a:fontRef idx="minor">
-            <a:schemeClr val="lt1"/>
-          </a:fontRef>
-        </p:style>
-        <p:txBody>
-          <a:bodyPr rtlCol="0" anchor="ctr"/>
-          <a:lstStyle/>
-          <a:p>
-            <a:pPr algn="ctr"/>
-          </a:p>
-        </p:txBody>
-      </p:sp>
-      <p:sp>
-        <p:nvSpPr>
-          <p:cNvPr id="6" name="TextBox 5"/>
-          <p:cNvSpPr txBox="1"/>
-          <p:nvPr/>
-        </p:nvSpPr>
-        <p:spPr>
-          <a:xfrm>
-            <a:off x="548640" y="6473952"/>
-            <a:ext cx="3657600" cy="274320"/>
-          </a:xfrm>
-          <a:prstGeom prst="rect">
-            <a:avLst/>
-          </a:prstGeom>
-          <a:noFill/>
-        </p:spPr>
-        <p:txBody>
-          <a:bodyPr wrap="square" anchor="t">
-            <a:noAutofit/>
-          </a:bodyPr>
-          <a:lstStyle/>
-          <a:p>
-            <a:pPr algn="l">
-              <a:lnSpc>
-                <a:spcPct val="100000"/>
-              </a:lnSpc>
-            </a:pPr>
-            <a:r>
-              <a:rPr sz="1000" b="1">
-                <a:solidFill>
-                  <a:srgbClr val="6B6F76"/>
-                </a:solidFill>
-                <a:latin typeface="Arial"/>
-              </a:rPr>
-              <a:t>TECHPAPY</a:t>
-            </a:r>
-          </a:p>
-        </p:txBody>
-      </p:sp>
-      <p:sp>
-        <p:nvSpPr>
-          <p:cNvPr id="7" name="TextBox 6"/>
-          <p:cNvSpPr txBox="1"/>
-          <p:nvPr/>
-        </p:nvSpPr>
-        <p:spPr>
-          <a:xfrm>
-            <a:off x="11155680" y="6473952"/>
-            <a:ext cx="548640" cy="274320"/>
-          </a:xfrm>
-          <a:prstGeom prst="rect">
-            <a:avLst/>
-          </a:prstGeom>
-          <a:noFill/>
-        </p:spPr>
-        <p:txBody>
-          <a:bodyPr wrap="square" anchor="t">
-            <a:noAutofit/>
-          </a:bodyPr>
-          <a:lstStyle/>
-          <a:p>
-            <a:pPr algn="r">
-              <a:lnSpc>
-                <a:spcPct val="100000"/>
-              </a:lnSpc>
-            </a:pPr>
-            <a:r>
-              <a:rPr sz="1000" b="1">
-                <a:solidFill>
-                  <a:srgbClr val="6B6F76"/>
-                </a:solidFill>
-                <a:latin typeface="Arial"/>
-              </a:rPr>
-              <a:t>10</a:t>
-            </a:r>
-          </a:p>
-        </p:txBody>
-      </p:sp>
-      <p:sp>
-        <p:nvSpPr>
-          <p:cNvPr id="8" name="Rectangle 7"/>
-          <p:cNvSpPr/>
-          <p:nvPr/>
-        </p:nvSpPr>
-        <p:spPr>
-          <a:xfrm>
-            <a:off x="548640" y="6419088"/>
-            <a:ext cx="11064240" cy="12700"/>
           </a:xfrm>
           <a:prstGeom prst="rect">
             <a:avLst/>
@@ -3777,20 +3673,88 @@
       </p:sp>
       <p:sp>
         <p:nvSpPr>
+          <p:cNvPr id="7" name="TextBox 6"/>
+          <p:cNvSpPr txBox="1"/>
+          <p:nvPr/>
+        </p:nvSpPr>
+        <p:spPr>
+          <a:xfrm>
+            <a:off x="548640" y="6473952"/>
+            <a:ext cx="3657600" cy="274320"/>
+          </a:xfrm>
+          <a:prstGeom prst="rect">
+            <a:avLst/>
+          </a:prstGeom>
+          <a:noFill/>
+        </p:spPr>
+        <p:txBody>
+          <a:bodyPr wrap="square">
+            <a:spAutoFit/>
+          </a:bodyPr>
+          <a:lstStyle/>
+          <a:p>
+            <a:pPr algn="l"/>
+            <a:r>
+              <a:rPr sz="1100" b="1">
+                <a:solidFill>
+                  <a:srgbClr val="111318"/>
+                </a:solidFill>
+              </a:rPr>
+              <a:t>TECHPAPY</a:t>
+            </a:r>
+          </a:p>
+        </p:txBody>
+      </p:sp>
+      <p:sp>
+        <p:nvSpPr>
+          <p:cNvPr id="8" name="TextBox 7"/>
+          <p:cNvSpPr txBox="1"/>
+          <p:nvPr/>
+        </p:nvSpPr>
+        <p:spPr>
+          <a:xfrm>
+            <a:off x="11155680" y="6473952"/>
+            <a:ext cx="548640" cy="274320"/>
+          </a:xfrm>
+          <a:prstGeom prst="rect">
+            <a:avLst/>
+          </a:prstGeom>
+          <a:noFill/>
+        </p:spPr>
+        <p:txBody>
+          <a:bodyPr wrap="square">
+            <a:spAutoFit/>
+          </a:bodyPr>
+          <a:lstStyle/>
+          <a:p>
+            <a:pPr algn="r"/>
+            <a:r>
+              <a:rPr sz="1100" b="1">
+                <a:solidFill>
+                  <a:srgbClr val="111318"/>
+                </a:solidFill>
+              </a:rPr>
+              <a:t>10</a:t>
+            </a:r>
+          </a:p>
+        </p:txBody>
+      </p:sp>
+      <p:sp>
+        <p:nvSpPr>
           <p:cNvPr id="9" name="Rectangle 8"/>
           <p:cNvSpPr/>
           <p:nvPr/>
         </p:nvSpPr>
         <p:spPr>
           <a:xfrm>
-            <a:off x="548640" y="1920240"/>
-            <a:ext cx="11064240" cy="566928"/>
+            <a:off x="548640" y="6419088"/>
+            <a:ext cx="11064240" cy="12700"/>
           </a:xfrm>
           <a:prstGeom prst="rect">
             <a:avLst/>
           </a:prstGeom>
           <a:solidFill>
-            <a:srgbClr val="F2F3F5"/>
+            <a:srgbClr val="D8DADF"/>
           </a:solidFill>
           <a:ln>
             <a:noFill/>
@@ -3819,694 +3783,30 @@
           </a:p>
         </p:txBody>
       </p:sp>
-      <p:sp>
-        <p:nvSpPr>
-          <p:cNvPr id="10" name="TextBox 9"/>
-          <p:cNvSpPr txBox="1"/>
-          <p:nvPr/>
-        </p:nvSpPr>
-        <p:spPr>
-          <a:xfrm>
-            <a:off x="822960" y="2029968"/>
-            <a:ext cx="2926080" cy="365760"/>
-          </a:xfrm>
-          <a:prstGeom prst="rect">
-            <a:avLst/>
-          </a:prstGeom>
-          <a:noFill/>
-        </p:spPr>
-        <p:txBody>
-          <a:bodyPr wrap="square" anchor="t">
-            <a:noAutofit/>
-          </a:bodyPr>
-          <a:lstStyle/>
-          <a:p>
-            <a:pPr algn="l">
-              <a:lnSpc>
-                <a:spcPct val="100000"/>
-              </a:lnSpc>
-            </a:pPr>
-            <a:r>
-              <a:rPr sz="1400" b="1">
-                <a:solidFill>
-                  <a:srgbClr val="111318"/>
-                </a:solidFill>
-                <a:latin typeface="Arial"/>
-              </a:rPr>
-              <a:t>Frontend</a:t>
-            </a:r>
-          </a:p>
-        </p:txBody>
-      </p:sp>
-      <p:sp>
-        <p:nvSpPr>
-          <p:cNvPr id="11" name="TextBox 10"/>
-          <p:cNvSpPr txBox="1"/>
-          <p:nvPr/>
-        </p:nvSpPr>
-        <p:spPr>
-          <a:xfrm>
-            <a:off x="3931920" y="2029968"/>
-            <a:ext cx="7498079" cy="365760"/>
-          </a:xfrm>
-          <a:prstGeom prst="rect">
-            <a:avLst/>
-          </a:prstGeom>
-          <a:noFill/>
-        </p:spPr>
-        <p:txBody>
-          <a:bodyPr wrap="square" anchor="t">
-            <a:noAutofit/>
-          </a:bodyPr>
-          <a:lstStyle/>
-          <a:p>
-            <a:pPr algn="l">
-              <a:lnSpc>
-                <a:spcPct val="100000"/>
-              </a:lnSpc>
-            </a:pPr>
-            <a:r>
-              <a:rPr sz="1400" b="0">
-                <a:solidFill>
-                  <a:srgbClr val="6B6F76"/>
-                </a:solidFill>
-                <a:latin typeface="Arial"/>
-              </a:rPr>
-              <a:t>Next.js 16, TypeScript, Tailwind CSS</a:t>
-            </a:r>
-          </a:p>
-        </p:txBody>
-      </p:sp>
-      <p:sp>
-        <p:nvSpPr>
-          <p:cNvPr id="12" name="Rectangle 11"/>
-          <p:cNvSpPr/>
-          <p:nvPr/>
-        </p:nvSpPr>
-        <p:spPr>
-          <a:xfrm>
-            <a:off x="548640" y="2487168"/>
-            <a:ext cx="11064240" cy="566928"/>
-          </a:xfrm>
-          <a:prstGeom prst="rect">
-            <a:avLst/>
-          </a:prstGeom>
-          <a:solidFill>
-            <a:srgbClr val="FFFFFF"/>
-          </a:solidFill>
-          <a:ln>
-            <a:noFill/>
-          </a:ln>
-          <a:effectLst/>
-        </p:spPr>
-        <p:style>
-          <a:lnRef idx="1">
-            <a:schemeClr val="accent1"/>
-          </a:lnRef>
-          <a:fillRef idx="3">
-            <a:schemeClr val="accent1"/>
-          </a:fillRef>
-          <a:effectRef idx="2">
-            <a:schemeClr val="accent1"/>
-          </a:effectRef>
-          <a:fontRef idx="minor">
-            <a:schemeClr val="lt1"/>
-          </a:fontRef>
-        </p:style>
-        <p:txBody>
-          <a:bodyPr rtlCol="0" anchor="ctr"/>
-          <a:lstStyle/>
-          <a:p>
-            <a:pPr algn="ctr"/>
-          </a:p>
-        </p:txBody>
-      </p:sp>
-      <p:sp>
-        <p:nvSpPr>
-          <p:cNvPr id="13" name="TextBox 12"/>
-          <p:cNvSpPr txBox="1"/>
-          <p:nvPr/>
-        </p:nvSpPr>
-        <p:spPr>
-          <a:xfrm>
-            <a:off x="822960" y="2596896"/>
-            <a:ext cx="2926080" cy="365760"/>
-          </a:xfrm>
-          <a:prstGeom prst="rect">
-            <a:avLst/>
-          </a:prstGeom>
-          <a:noFill/>
-        </p:spPr>
-        <p:txBody>
-          <a:bodyPr wrap="square" anchor="t">
-            <a:noAutofit/>
-          </a:bodyPr>
-          <a:lstStyle/>
-          <a:p>
-            <a:pPr algn="l">
-              <a:lnSpc>
-                <a:spcPct val="100000"/>
-              </a:lnSpc>
-            </a:pPr>
-            <a:r>
-              <a:rPr sz="1400" b="1">
-                <a:solidFill>
-                  <a:srgbClr val="111318"/>
-                </a:solidFill>
-                <a:latin typeface="Arial"/>
-              </a:rPr>
-              <a:t>Backend</a:t>
-            </a:r>
-          </a:p>
-        </p:txBody>
-      </p:sp>
-      <p:sp>
-        <p:nvSpPr>
-          <p:cNvPr id="14" name="TextBox 13"/>
-          <p:cNvSpPr txBox="1"/>
-          <p:nvPr/>
-        </p:nvSpPr>
-        <p:spPr>
-          <a:xfrm>
-            <a:off x="3931920" y="2596896"/>
-            <a:ext cx="7498079" cy="365760"/>
-          </a:xfrm>
-          <a:prstGeom prst="rect">
-            <a:avLst/>
-          </a:prstGeom>
-          <a:noFill/>
-        </p:spPr>
-        <p:txBody>
-          <a:bodyPr wrap="square" anchor="t">
-            <a:noAutofit/>
-          </a:bodyPr>
-          <a:lstStyle/>
-          <a:p>
-            <a:pPr algn="l">
-              <a:lnSpc>
-                <a:spcPct val="100000"/>
-              </a:lnSpc>
-            </a:pPr>
-            <a:r>
-              <a:rPr sz="1400" b="0">
-                <a:solidFill>
-                  <a:srgbClr val="6B6F76"/>
-                </a:solidFill>
-                <a:latin typeface="Arial"/>
-              </a:rPr>
-              <a:t>Express, TypeScript, Prisma ORM</a:t>
-            </a:r>
-          </a:p>
-        </p:txBody>
-      </p:sp>
-      <p:sp>
-        <p:nvSpPr>
-          <p:cNvPr id="15" name="Rectangle 14"/>
-          <p:cNvSpPr/>
-          <p:nvPr/>
-        </p:nvSpPr>
-        <p:spPr>
-          <a:xfrm>
-            <a:off x="548640" y="3054096"/>
-            <a:ext cx="11064240" cy="566928"/>
-          </a:xfrm>
-          <a:prstGeom prst="rect">
-            <a:avLst/>
-          </a:prstGeom>
-          <a:solidFill>
-            <a:srgbClr val="F2F3F5"/>
-          </a:solidFill>
-          <a:ln>
-            <a:noFill/>
-          </a:ln>
-          <a:effectLst/>
-        </p:spPr>
-        <p:style>
-          <a:lnRef idx="1">
-            <a:schemeClr val="accent1"/>
-          </a:lnRef>
-          <a:fillRef idx="3">
-            <a:schemeClr val="accent1"/>
-          </a:fillRef>
-          <a:effectRef idx="2">
-            <a:schemeClr val="accent1"/>
-          </a:effectRef>
-          <a:fontRef idx="minor">
-            <a:schemeClr val="lt1"/>
-          </a:fontRef>
-        </p:style>
-        <p:txBody>
-          <a:bodyPr rtlCol="0" anchor="ctr"/>
-          <a:lstStyle/>
-          <a:p>
-            <a:pPr algn="ctr"/>
-          </a:p>
-        </p:txBody>
-      </p:sp>
-      <p:sp>
-        <p:nvSpPr>
-          <p:cNvPr id="16" name="TextBox 15"/>
-          <p:cNvSpPr txBox="1"/>
-          <p:nvPr/>
-        </p:nvSpPr>
-        <p:spPr>
-          <a:xfrm>
-            <a:off x="822960" y="3163824"/>
-            <a:ext cx="2926080" cy="365760"/>
-          </a:xfrm>
-          <a:prstGeom prst="rect">
-            <a:avLst/>
-          </a:prstGeom>
-          <a:noFill/>
-        </p:spPr>
-        <p:txBody>
-          <a:bodyPr wrap="square" anchor="t">
-            <a:noAutofit/>
-          </a:bodyPr>
-          <a:lstStyle/>
-          <a:p>
-            <a:pPr algn="l">
-              <a:lnSpc>
-                <a:spcPct val="100000"/>
-              </a:lnSpc>
-            </a:pPr>
-            <a:r>
-              <a:rPr sz="1400" b="1">
-                <a:solidFill>
-                  <a:srgbClr val="111318"/>
-                </a:solidFill>
-                <a:latin typeface="Arial"/>
-              </a:rPr>
-              <a:t>Base de données</a:t>
-            </a:r>
-          </a:p>
-        </p:txBody>
-      </p:sp>
-      <p:sp>
-        <p:nvSpPr>
-          <p:cNvPr id="17" name="TextBox 16"/>
-          <p:cNvSpPr txBox="1"/>
-          <p:nvPr/>
-        </p:nvSpPr>
-        <p:spPr>
-          <a:xfrm>
-            <a:off x="3931920" y="3163824"/>
-            <a:ext cx="7498079" cy="365760"/>
-          </a:xfrm>
-          <a:prstGeom prst="rect">
-            <a:avLst/>
-          </a:prstGeom>
-          <a:noFill/>
-        </p:spPr>
-        <p:txBody>
-          <a:bodyPr wrap="square" anchor="t">
-            <a:noAutofit/>
-          </a:bodyPr>
-          <a:lstStyle/>
-          <a:p>
-            <a:pPr algn="l">
-              <a:lnSpc>
-                <a:spcPct val="100000"/>
-              </a:lnSpc>
-            </a:pPr>
-            <a:r>
-              <a:rPr sz="1400" b="0">
-                <a:solidFill>
-                  <a:srgbClr val="6B6F76"/>
-                </a:solidFill>
-                <a:latin typeface="Arial"/>
-              </a:rPr>
-              <a:t>PostgreSQL (Cloud SQL)</a:t>
-            </a:r>
-          </a:p>
-        </p:txBody>
-      </p:sp>
-      <p:sp>
-        <p:nvSpPr>
-          <p:cNvPr id="18" name="Rectangle 17"/>
-          <p:cNvSpPr/>
-          <p:nvPr/>
-        </p:nvSpPr>
-        <p:spPr>
-          <a:xfrm>
-            <a:off x="548640" y="3621024"/>
-            <a:ext cx="11064240" cy="566928"/>
-          </a:xfrm>
-          <a:prstGeom prst="rect">
-            <a:avLst/>
-          </a:prstGeom>
-          <a:solidFill>
-            <a:srgbClr val="FFFFFF"/>
-          </a:solidFill>
-          <a:ln>
-            <a:noFill/>
-          </a:ln>
-          <a:effectLst/>
-        </p:spPr>
-        <p:style>
-          <a:lnRef idx="1">
-            <a:schemeClr val="accent1"/>
-          </a:lnRef>
-          <a:fillRef idx="3">
-            <a:schemeClr val="accent1"/>
-          </a:fillRef>
-          <a:effectRef idx="2">
-            <a:schemeClr val="accent1"/>
-          </a:effectRef>
-          <a:fontRef idx="minor">
-            <a:schemeClr val="lt1"/>
-          </a:fontRef>
-        </p:style>
-        <p:txBody>
-          <a:bodyPr rtlCol="0" anchor="ctr"/>
-          <a:lstStyle/>
-          <a:p>
-            <a:pPr algn="ctr"/>
-          </a:p>
-        </p:txBody>
-      </p:sp>
-      <p:sp>
-        <p:nvSpPr>
-          <p:cNvPr id="19" name="TextBox 18"/>
-          <p:cNvSpPr txBox="1"/>
-          <p:nvPr/>
-        </p:nvSpPr>
-        <p:spPr>
-          <a:xfrm>
-            <a:off x="822960" y="3730752"/>
-            <a:ext cx="2926080" cy="365760"/>
-          </a:xfrm>
-          <a:prstGeom prst="rect">
-            <a:avLst/>
-          </a:prstGeom>
-          <a:noFill/>
-        </p:spPr>
-        <p:txBody>
-          <a:bodyPr wrap="square" anchor="t">
-            <a:noAutofit/>
-          </a:bodyPr>
-          <a:lstStyle/>
-          <a:p>
-            <a:pPr algn="l">
-              <a:lnSpc>
-                <a:spcPct val="100000"/>
-              </a:lnSpc>
-            </a:pPr>
-            <a:r>
-              <a:rPr sz="1400" b="1">
-                <a:solidFill>
-                  <a:srgbClr val="111318"/>
-                </a:solidFill>
-                <a:latin typeface="Arial"/>
-              </a:rPr>
-              <a:t>Visioconférence</a:t>
-            </a:r>
-          </a:p>
-        </p:txBody>
-      </p:sp>
-      <p:sp>
-        <p:nvSpPr>
-          <p:cNvPr id="20" name="TextBox 19"/>
-          <p:cNvSpPr txBox="1"/>
-          <p:nvPr/>
-        </p:nvSpPr>
-        <p:spPr>
-          <a:xfrm>
-            <a:off x="3931920" y="3730752"/>
-            <a:ext cx="7498079" cy="365760"/>
-          </a:xfrm>
-          <a:prstGeom prst="rect">
-            <a:avLst/>
-          </a:prstGeom>
-          <a:noFill/>
-        </p:spPr>
-        <p:txBody>
-          <a:bodyPr wrap="square" anchor="t">
-            <a:noAutofit/>
-          </a:bodyPr>
-          <a:lstStyle/>
-          <a:p>
-            <a:pPr algn="l">
-              <a:lnSpc>
-                <a:spcPct val="100000"/>
-              </a:lnSpc>
-            </a:pPr>
-            <a:r>
-              <a:rPr sz="1400" b="0">
-                <a:solidFill>
-                  <a:srgbClr val="6B6F76"/>
-                </a:solidFill>
-                <a:latin typeface="Arial"/>
-              </a:rPr>
-              <a:t>WebRTC (simple-peer) + Socket.IO</a:t>
-            </a:r>
-          </a:p>
-        </p:txBody>
-      </p:sp>
-      <p:sp>
-        <p:nvSpPr>
-          <p:cNvPr id="21" name="Rectangle 20"/>
-          <p:cNvSpPr/>
-          <p:nvPr/>
-        </p:nvSpPr>
-        <p:spPr>
-          <a:xfrm>
-            <a:off x="548640" y="4187952"/>
-            <a:ext cx="11064240" cy="566928"/>
-          </a:xfrm>
-          <a:prstGeom prst="rect">
-            <a:avLst/>
-          </a:prstGeom>
-          <a:solidFill>
-            <a:srgbClr val="F2F3F5"/>
-          </a:solidFill>
-          <a:ln>
-            <a:noFill/>
-          </a:ln>
-          <a:effectLst/>
-        </p:spPr>
-        <p:style>
-          <a:lnRef idx="1">
-            <a:schemeClr val="accent1"/>
-          </a:lnRef>
-          <a:fillRef idx="3">
-            <a:schemeClr val="accent1"/>
-          </a:fillRef>
-          <a:effectRef idx="2">
-            <a:schemeClr val="accent1"/>
-          </a:effectRef>
-          <a:fontRef idx="minor">
-            <a:schemeClr val="lt1"/>
-          </a:fontRef>
-        </p:style>
-        <p:txBody>
-          <a:bodyPr rtlCol="0" anchor="ctr"/>
-          <a:lstStyle/>
-          <a:p>
-            <a:pPr algn="ctr"/>
-          </a:p>
-        </p:txBody>
-      </p:sp>
-      <p:sp>
-        <p:nvSpPr>
-          <p:cNvPr id="22" name="TextBox 21"/>
-          <p:cNvSpPr txBox="1"/>
-          <p:nvPr/>
-        </p:nvSpPr>
-        <p:spPr>
-          <a:xfrm>
-            <a:off x="822960" y="4297680"/>
-            <a:ext cx="2926080" cy="365760"/>
-          </a:xfrm>
-          <a:prstGeom prst="rect">
-            <a:avLst/>
-          </a:prstGeom>
-          <a:noFill/>
-        </p:spPr>
-        <p:txBody>
-          <a:bodyPr wrap="square" anchor="t">
-            <a:noAutofit/>
-          </a:bodyPr>
-          <a:lstStyle/>
-          <a:p>
-            <a:pPr algn="l">
-              <a:lnSpc>
-                <a:spcPct val="100000"/>
-              </a:lnSpc>
-            </a:pPr>
-            <a:r>
-              <a:rPr sz="1400" b="1">
-                <a:solidFill>
-                  <a:srgbClr val="111318"/>
-                </a:solidFill>
-                <a:latin typeface="Arial"/>
-              </a:rPr>
-              <a:t>Cloud</a:t>
-            </a:r>
-          </a:p>
-        </p:txBody>
-      </p:sp>
-      <p:sp>
-        <p:nvSpPr>
-          <p:cNvPr id="23" name="TextBox 22"/>
-          <p:cNvSpPr txBox="1"/>
-          <p:nvPr/>
-        </p:nvSpPr>
-        <p:spPr>
-          <a:xfrm>
-            <a:off x="3931920" y="4297680"/>
-            <a:ext cx="7498079" cy="365760"/>
-          </a:xfrm>
-          <a:prstGeom prst="rect">
-            <a:avLst/>
-          </a:prstGeom>
-          <a:noFill/>
-        </p:spPr>
-        <p:txBody>
-          <a:bodyPr wrap="square" anchor="t">
-            <a:noAutofit/>
-          </a:bodyPr>
-          <a:lstStyle/>
-          <a:p>
-            <a:pPr algn="l">
-              <a:lnSpc>
-                <a:spcPct val="100000"/>
-              </a:lnSpc>
-            </a:pPr>
-            <a:r>
-              <a:rPr sz="1400" b="0">
-                <a:solidFill>
-                  <a:srgbClr val="6B6F76"/>
-                </a:solidFill>
-                <a:latin typeface="Arial"/>
-              </a:rPr>
-              <a:t>Google Cloud Platform (Cloud Run, Cloud SQL)</a:t>
-            </a:r>
-          </a:p>
-        </p:txBody>
-      </p:sp>
-      <p:sp>
-        <p:nvSpPr>
-          <p:cNvPr id="24" name="Rectangle 23"/>
-          <p:cNvSpPr/>
-          <p:nvPr/>
-        </p:nvSpPr>
-        <p:spPr>
-          <a:xfrm>
-            <a:off x="548640" y="4754880"/>
-            <a:ext cx="11064240" cy="566928"/>
-          </a:xfrm>
-          <a:prstGeom prst="rect">
-            <a:avLst/>
-          </a:prstGeom>
-          <a:solidFill>
-            <a:srgbClr val="FFFFFF"/>
-          </a:solidFill>
-          <a:ln>
-            <a:noFill/>
-          </a:ln>
-          <a:effectLst/>
-        </p:spPr>
-        <p:style>
-          <a:lnRef idx="1">
-            <a:schemeClr val="accent1"/>
-          </a:lnRef>
-          <a:fillRef idx="3">
-            <a:schemeClr val="accent1"/>
-          </a:fillRef>
-          <a:effectRef idx="2">
-            <a:schemeClr val="accent1"/>
-          </a:effectRef>
-          <a:fontRef idx="minor">
-            <a:schemeClr val="lt1"/>
-          </a:fontRef>
-        </p:style>
-        <p:txBody>
-          <a:bodyPr rtlCol="0" anchor="ctr"/>
-          <a:lstStyle/>
-          <a:p>
-            <a:pPr algn="ctr"/>
-          </a:p>
-        </p:txBody>
-      </p:sp>
-      <p:sp>
-        <p:nvSpPr>
-          <p:cNvPr id="25" name="TextBox 24"/>
-          <p:cNvSpPr txBox="1"/>
-          <p:nvPr/>
-        </p:nvSpPr>
-        <p:spPr>
-          <a:xfrm>
-            <a:off x="822960" y="4864608"/>
-            <a:ext cx="2926080" cy="365760"/>
-          </a:xfrm>
-          <a:prstGeom prst="rect">
-            <a:avLst/>
-          </a:prstGeom>
-          <a:noFill/>
-        </p:spPr>
-        <p:txBody>
-          <a:bodyPr wrap="square" anchor="t">
-            <a:noAutofit/>
-          </a:bodyPr>
-          <a:lstStyle/>
-          <a:p>
-            <a:pPr algn="l">
-              <a:lnSpc>
-                <a:spcPct val="100000"/>
-              </a:lnSpc>
-            </a:pPr>
-            <a:r>
-              <a:rPr sz="1400" b="1">
-                <a:solidFill>
-                  <a:srgbClr val="111318"/>
-                </a:solidFill>
-                <a:latin typeface="Arial"/>
-              </a:rPr>
-              <a:t>CI/CD</a:t>
-            </a:r>
-          </a:p>
-        </p:txBody>
-      </p:sp>
-      <p:sp>
-        <p:nvSpPr>
-          <p:cNvPr id="26" name="TextBox 25"/>
-          <p:cNvSpPr txBox="1"/>
-          <p:nvPr/>
-        </p:nvSpPr>
-        <p:spPr>
-          <a:xfrm>
-            <a:off x="3931920" y="4864608"/>
-            <a:ext cx="7498079" cy="365760"/>
-          </a:xfrm>
-          <a:prstGeom prst="rect">
-            <a:avLst/>
-          </a:prstGeom>
-          <a:noFill/>
-        </p:spPr>
-        <p:txBody>
-          <a:bodyPr wrap="square" anchor="t">
-            <a:noAutofit/>
-          </a:bodyPr>
-          <a:lstStyle/>
-          <a:p>
-            <a:pPr algn="l">
-              <a:lnSpc>
-                <a:spcPct val="100000"/>
-              </a:lnSpc>
-            </a:pPr>
-            <a:r>
-              <a:rPr sz="1400" b="0">
-                <a:solidFill>
-                  <a:srgbClr val="6B6F76"/>
-                </a:solidFill>
-                <a:latin typeface="Arial"/>
-              </a:rPr>
-              <a:t>GitHub Actions</a:t>
-            </a:r>
-          </a:p>
-        </p:txBody>
-      </p:sp>
+      <p:pic>
+        <p:nvPicPr>
+          <p:cNvPr id="10" name="Picture 9" descr="infrastructure_gcp.png"/>
+          <p:cNvPicPr>
+            <a:picLocks noChangeAspect="1"/>
+          </p:cNvPicPr>
+          <p:nvPr/>
+        </p:nvPicPr>
+        <p:blipFill>
+          <a:blip r:embed="rId2"/>
+          <a:stretch>
+            <a:fillRect/>
+          </a:stretch>
+        </p:blipFill>
+        <p:spPr>
+          <a:xfrm>
+            <a:off x="2374759" y="1750000"/>
+            <a:ext cx="7442176" cy="4300000"/>
+          </a:xfrm>
+          <a:prstGeom prst="rect">
+            <a:avLst/>
+          </a:prstGeom>
+        </p:spPr>
+      </p:pic>
     </p:spTree>
   </p:cSld>
   <p:clrMapOvr>
@@ -4540,7 +3840,7 @@
             <a:avLst/>
           </a:prstGeom>
           <a:solidFill>
-            <a:srgbClr val="111318"/>
+            <a:srgbClr val="FFFFFF"/>
           </a:solidFill>
           <a:ln>
             <a:noFill/>
@@ -4577,8 +3877,8 @@
         </p:nvSpPr>
         <p:spPr>
           <a:xfrm>
-            <a:off x="-1097280" y="-1097280"/>
-            <a:ext cx="2926080" cy="2926080"/>
+            <a:off x="548640" y="457200"/>
+            <a:ext cx="1143000" cy="310896"/>
           </a:xfrm>
           <a:prstGeom prst="rect">
             <a:avLst/>
@@ -4606,10 +3906,21 @@
           </a:fontRef>
         </p:style>
         <p:txBody>
-          <a:bodyPr rtlCol="0" anchor="ctr"/>
+          <a:bodyPr rtlCol="0" anchor="ctr" wrap="none" lIns="109728" rIns="109728" tIns="18288" bIns="18288">
+            <a:noAutofit/>
+          </a:bodyPr>
           <a:lstStyle/>
           <a:p>
             <a:pPr algn="ctr"/>
+            <a:r>
+              <a:rPr sz="1200" b="1">
+                <a:solidFill>
+                  <a:srgbClr val="111318"/>
+                </a:solidFill>
+                <a:latin typeface="Arial"/>
+              </a:rPr>
+              <a:t>STACK</a:t>
+            </a:r>
           </a:p>
         </p:txBody>
       </p:sp>
@@ -4621,8 +3932,8 @@
         </p:nvSpPr>
         <p:spPr>
           <a:xfrm>
-            <a:off x="822960" y="2743200"/>
-            <a:ext cx="1828800" cy="1097280"/>
+            <a:off x="530352" y="868680"/>
+            <a:ext cx="10789920" cy="822960"/>
           </a:xfrm>
           <a:prstGeom prst="rect">
             <a:avLst/>
@@ -4641,27 +3952,71 @@
               </a:lnSpc>
             </a:pPr>
             <a:r>
-              <a:rPr sz="7200" b="1">
-                <a:solidFill>
-                  <a:srgbClr val="33353D"/>
-                </a:solidFill>
-                <a:latin typeface="Arial"/>
-              </a:rPr>
-              <a:t>03</a:t>
-            </a:r>
-          </a:p>
-        </p:txBody>
-      </p:sp>
-      <p:sp>
-        <p:nvSpPr>
-          <p:cNvPr id="5" name="TextBox 4"/>
+              <a:rPr sz="3000" b="1">
+                <a:solidFill>
+                  <a:srgbClr val="111318"/>
+                </a:solidFill>
+                <a:latin typeface="Arial"/>
+              </a:rPr>
+              <a:t>STACK TECHNIQUE</a:t>
+            </a:r>
+          </a:p>
+        </p:txBody>
+      </p:sp>
+      <p:sp>
+        <p:nvSpPr>
+          <p:cNvPr id="5" name="Rectangle 4"/>
+          <p:cNvSpPr/>
+          <p:nvPr/>
+        </p:nvSpPr>
+        <p:spPr>
+          <a:xfrm>
+            <a:off x="548640" y="1536192"/>
+            <a:ext cx="11064240" cy="19050"/>
+          </a:xfrm>
+          <a:prstGeom prst="rect">
+            <a:avLst/>
+          </a:prstGeom>
+          <a:solidFill>
+            <a:srgbClr val="111318"/>
+          </a:solidFill>
+          <a:ln>
+            <a:noFill/>
+          </a:ln>
+          <a:effectLst/>
+        </p:spPr>
+        <p:style>
+          <a:lnRef idx="1">
+            <a:schemeClr val="accent1"/>
+          </a:lnRef>
+          <a:fillRef idx="3">
+            <a:schemeClr val="accent1"/>
+          </a:fillRef>
+          <a:effectRef idx="2">
+            <a:schemeClr val="accent1"/>
+          </a:effectRef>
+          <a:fontRef idx="minor">
+            <a:schemeClr val="lt1"/>
+          </a:fontRef>
+        </p:style>
+        <p:txBody>
+          <a:bodyPr rtlCol="0" anchor="ctr"/>
+          <a:lstStyle/>
+          <a:p>
+            <a:pPr algn="ctr"/>
+          </a:p>
+        </p:txBody>
+      </p:sp>
+      <p:sp>
+        <p:nvSpPr>
+          <p:cNvPr id="6" name="TextBox 5"/>
           <p:cNvSpPr txBox="1"/>
           <p:nvPr/>
         </p:nvSpPr>
         <p:spPr>
           <a:xfrm>
-            <a:off x="822960" y="3566160"/>
-            <a:ext cx="10058400" cy="1097280"/>
+            <a:off x="548640" y="6473952"/>
+            <a:ext cx="3657600" cy="274320"/>
           </a:xfrm>
           <a:prstGeom prst="rect">
             <a:avLst/>
@@ -4680,27 +4035,154 @@
               </a:lnSpc>
             </a:pPr>
             <a:r>
-              <a:rPr sz="4000" b="1">
-                <a:solidFill>
-                  <a:srgbClr val="FFFFFF"/>
-                </a:solidFill>
-                <a:latin typeface="Arial"/>
-              </a:rPr>
-              <a:t>BILAN DU PROJET</a:t>
-            </a:r>
-          </a:p>
-        </p:txBody>
-      </p:sp>
-      <p:sp>
-        <p:nvSpPr>
-          <p:cNvPr id="6" name="TextBox 5"/>
+              <a:rPr sz="1000" b="1">
+                <a:solidFill>
+                  <a:srgbClr val="6B6F76"/>
+                </a:solidFill>
+                <a:latin typeface="Arial"/>
+              </a:rPr>
+              <a:t>TECHPAPY</a:t>
+            </a:r>
+          </a:p>
+        </p:txBody>
+      </p:sp>
+      <p:sp>
+        <p:nvSpPr>
+          <p:cNvPr id="7" name="TextBox 6"/>
           <p:cNvSpPr txBox="1"/>
           <p:nvPr/>
         </p:nvSpPr>
         <p:spPr>
           <a:xfrm>
-            <a:off x="841248" y="4343400"/>
-            <a:ext cx="9144000" cy="548640"/>
+            <a:off x="11155680" y="6473952"/>
+            <a:ext cx="548640" cy="274320"/>
+          </a:xfrm>
+          <a:prstGeom prst="rect">
+            <a:avLst/>
+          </a:prstGeom>
+          <a:noFill/>
+        </p:spPr>
+        <p:txBody>
+          <a:bodyPr wrap="square" anchor="t">
+            <a:noAutofit/>
+          </a:bodyPr>
+          <a:lstStyle/>
+          <a:p>
+            <a:pPr algn="r">
+              <a:lnSpc>
+                <a:spcPct val="100000"/>
+              </a:lnSpc>
+            </a:pPr>
+            <a:r>
+              <a:rPr sz="1000" b="1">
+                <a:solidFill>
+                  <a:srgbClr val="6B6F76"/>
+                </a:solidFill>
+                <a:latin typeface="Arial"/>
+              </a:rPr>
+              <a:t>11</a:t>
+            </a:r>
+          </a:p>
+        </p:txBody>
+      </p:sp>
+      <p:sp>
+        <p:nvSpPr>
+          <p:cNvPr id="8" name="Rectangle 7"/>
+          <p:cNvSpPr/>
+          <p:nvPr/>
+        </p:nvSpPr>
+        <p:spPr>
+          <a:xfrm>
+            <a:off x="548640" y="6419088"/>
+            <a:ext cx="11064240" cy="12700"/>
+          </a:xfrm>
+          <a:prstGeom prst="rect">
+            <a:avLst/>
+          </a:prstGeom>
+          <a:solidFill>
+            <a:srgbClr val="D8DADF"/>
+          </a:solidFill>
+          <a:ln>
+            <a:noFill/>
+          </a:ln>
+          <a:effectLst/>
+        </p:spPr>
+        <p:style>
+          <a:lnRef idx="1">
+            <a:schemeClr val="accent1"/>
+          </a:lnRef>
+          <a:fillRef idx="3">
+            <a:schemeClr val="accent1"/>
+          </a:fillRef>
+          <a:effectRef idx="2">
+            <a:schemeClr val="accent1"/>
+          </a:effectRef>
+          <a:fontRef idx="minor">
+            <a:schemeClr val="lt1"/>
+          </a:fontRef>
+        </p:style>
+        <p:txBody>
+          <a:bodyPr rtlCol="0" anchor="ctr"/>
+          <a:lstStyle/>
+          <a:p>
+            <a:pPr algn="ctr"/>
+          </a:p>
+        </p:txBody>
+      </p:sp>
+      <p:sp>
+        <p:nvSpPr>
+          <p:cNvPr id="9" name="Rectangle 8"/>
+          <p:cNvSpPr/>
+          <p:nvPr/>
+        </p:nvSpPr>
+        <p:spPr>
+          <a:xfrm>
+            <a:off x="548640" y="1920240"/>
+            <a:ext cx="11064240" cy="566928"/>
+          </a:xfrm>
+          <a:prstGeom prst="rect">
+            <a:avLst/>
+          </a:prstGeom>
+          <a:solidFill>
+            <a:srgbClr val="F2F3F5"/>
+          </a:solidFill>
+          <a:ln>
+            <a:noFill/>
+          </a:ln>
+          <a:effectLst/>
+        </p:spPr>
+        <p:style>
+          <a:lnRef idx="1">
+            <a:schemeClr val="accent1"/>
+          </a:lnRef>
+          <a:fillRef idx="3">
+            <a:schemeClr val="accent1"/>
+          </a:fillRef>
+          <a:effectRef idx="2">
+            <a:schemeClr val="accent1"/>
+          </a:effectRef>
+          <a:fontRef idx="minor">
+            <a:schemeClr val="lt1"/>
+          </a:fontRef>
+        </p:style>
+        <p:txBody>
+          <a:bodyPr rtlCol="0" anchor="ctr"/>
+          <a:lstStyle/>
+          <a:p>
+            <a:pPr algn="ctr"/>
+          </a:p>
+        </p:txBody>
+      </p:sp>
+      <p:sp>
+        <p:nvSpPr>
+          <p:cNvPr id="10" name="TextBox 9"/>
+          <p:cNvSpPr txBox="1"/>
+          <p:nvPr/>
+        </p:nvSpPr>
+        <p:spPr>
+          <a:xfrm>
+            <a:off x="822960" y="2029968"/>
+            <a:ext cx="2926080" cy="365760"/>
           </a:xfrm>
           <a:prstGeom prst="rect">
             <a:avLst/>
@@ -4719,13 +4201,662 @@
               </a:lnSpc>
             </a:pPr>
             <a:r>
-              <a:rPr sz="1500" b="0">
+              <a:rPr sz="1400" b="1">
+                <a:solidFill>
+                  <a:srgbClr val="111318"/>
+                </a:solidFill>
+                <a:latin typeface="Arial"/>
+              </a:rPr>
+              <a:t>Frontend</a:t>
+            </a:r>
+          </a:p>
+        </p:txBody>
+      </p:sp>
+      <p:sp>
+        <p:nvSpPr>
+          <p:cNvPr id="11" name="TextBox 10"/>
+          <p:cNvSpPr txBox="1"/>
+          <p:nvPr/>
+        </p:nvSpPr>
+        <p:spPr>
+          <a:xfrm>
+            <a:off x="3931920" y="2029968"/>
+            <a:ext cx="7498079" cy="365760"/>
+          </a:xfrm>
+          <a:prstGeom prst="rect">
+            <a:avLst/>
+          </a:prstGeom>
+          <a:noFill/>
+        </p:spPr>
+        <p:txBody>
+          <a:bodyPr wrap="square" anchor="t">
+            <a:noAutofit/>
+          </a:bodyPr>
+          <a:lstStyle/>
+          <a:p>
+            <a:pPr algn="l">
+              <a:lnSpc>
+                <a:spcPct val="100000"/>
+              </a:lnSpc>
+            </a:pPr>
+            <a:r>
+              <a:rPr sz="1400" b="0">
                 <a:solidFill>
                   <a:srgbClr val="6B6F76"/>
                 </a:solidFill>
                 <a:latin typeface="Arial"/>
               </a:rPr>
-              <a:t>Ce qui est fait, ce qui reste</a:t>
+              <a:t>Next.js 16, TypeScript, Tailwind CSS</a:t>
+            </a:r>
+          </a:p>
+        </p:txBody>
+      </p:sp>
+      <p:sp>
+        <p:nvSpPr>
+          <p:cNvPr id="12" name="Rectangle 11"/>
+          <p:cNvSpPr/>
+          <p:nvPr/>
+        </p:nvSpPr>
+        <p:spPr>
+          <a:xfrm>
+            <a:off x="548640" y="2487168"/>
+            <a:ext cx="11064240" cy="566928"/>
+          </a:xfrm>
+          <a:prstGeom prst="rect">
+            <a:avLst/>
+          </a:prstGeom>
+          <a:solidFill>
+            <a:srgbClr val="FFFFFF"/>
+          </a:solidFill>
+          <a:ln>
+            <a:noFill/>
+          </a:ln>
+          <a:effectLst/>
+        </p:spPr>
+        <p:style>
+          <a:lnRef idx="1">
+            <a:schemeClr val="accent1"/>
+          </a:lnRef>
+          <a:fillRef idx="3">
+            <a:schemeClr val="accent1"/>
+          </a:fillRef>
+          <a:effectRef idx="2">
+            <a:schemeClr val="accent1"/>
+          </a:effectRef>
+          <a:fontRef idx="minor">
+            <a:schemeClr val="lt1"/>
+          </a:fontRef>
+        </p:style>
+        <p:txBody>
+          <a:bodyPr rtlCol="0" anchor="ctr"/>
+          <a:lstStyle/>
+          <a:p>
+            <a:pPr algn="ctr"/>
+          </a:p>
+        </p:txBody>
+      </p:sp>
+      <p:sp>
+        <p:nvSpPr>
+          <p:cNvPr id="13" name="TextBox 12"/>
+          <p:cNvSpPr txBox="1"/>
+          <p:nvPr/>
+        </p:nvSpPr>
+        <p:spPr>
+          <a:xfrm>
+            <a:off x="822960" y="2596896"/>
+            <a:ext cx="2926080" cy="365760"/>
+          </a:xfrm>
+          <a:prstGeom prst="rect">
+            <a:avLst/>
+          </a:prstGeom>
+          <a:noFill/>
+        </p:spPr>
+        <p:txBody>
+          <a:bodyPr wrap="square" anchor="t">
+            <a:noAutofit/>
+          </a:bodyPr>
+          <a:lstStyle/>
+          <a:p>
+            <a:pPr algn="l">
+              <a:lnSpc>
+                <a:spcPct val="100000"/>
+              </a:lnSpc>
+            </a:pPr>
+            <a:r>
+              <a:rPr sz="1400" b="1">
+                <a:solidFill>
+                  <a:srgbClr val="111318"/>
+                </a:solidFill>
+                <a:latin typeface="Arial"/>
+              </a:rPr>
+              <a:t>Backend</a:t>
+            </a:r>
+          </a:p>
+        </p:txBody>
+      </p:sp>
+      <p:sp>
+        <p:nvSpPr>
+          <p:cNvPr id="14" name="TextBox 13"/>
+          <p:cNvSpPr txBox="1"/>
+          <p:nvPr/>
+        </p:nvSpPr>
+        <p:spPr>
+          <a:xfrm>
+            <a:off x="3931920" y="2596896"/>
+            <a:ext cx="7498079" cy="365760"/>
+          </a:xfrm>
+          <a:prstGeom prst="rect">
+            <a:avLst/>
+          </a:prstGeom>
+          <a:noFill/>
+        </p:spPr>
+        <p:txBody>
+          <a:bodyPr wrap="square" anchor="t">
+            <a:noAutofit/>
+          </a:bodyPr>
+          <a:lstStyle/>
+          <a:p>
+            <a:pPr algn="l">
+              <a:lnSpc>
+                <a:spcPct val="100000"/>
+              </a:lnSpc>
+            </a:pPr>
+            <a:r>
+              <a:rPr sz="1400" b="0">
+                <a:solidFill>
+                  <a:srgbClr val="6B6F76"/>
+                </a:solidFill>
+                <a:latin typeface="Arial"/>
+              </a:rPr>
+              <a:t>Express, TypeScript, Prisma ORM</a:t>
+            </a:r>
+          </a:p>
+        </p:txBody>
+      </p:sp>
+      <p:sp>
+        <p:nvSpPr>
+          <p:cNvPr id="15" name="Rectangle 14"/>
+          <p:cNvSpPr/>
+          <p:nvPr/>
+        </p:nvSpPr>
+        <p:spPr>
+          <a:xfrm>
+            <a:off x="548640" y="3054096"/>
+            <a:ext cx="11064240" cy="566928"/>
+          </a:xfrm>
+          <a:prstGeom prst="rect">
+            <a:avLst/>
+          </a:prstGeom>
+          <a:solidFill>
+            <a:srgbClr val="F2F3F5"/>
+          </a:solidFill>
+          <a:ln>
+            <a:noFill/>
+          </a:ln>
+          <a:effectLst/>
+        </p:spPr>
+        <p:style>
+          <a:lnRef idx="1">
+            <a:schemeClr val="accent1"/>
+          </a:lnRef>
+          <a:fillRef idx="3">
+            <a:schemeClr val="accent1"/>
+          </a:fillRef>
+          <a:effectRef idx="2">
+            <a:schemeClr val="accent1"/>
+          </a:effectRef>
+          <a:fontRef idx="minor">
+            <a:schemeClr val="lt1"/>
+          </a:fontRef>
+        </p:style>
+        <p:txBody>
+          <a:bodyPr rtlCol="0" anchor="ctr"/>
+          <a:lstStyle/>
+          <a:p>
+            <a:pPr algn="ctr"/>
+          </a:p>
+        </p:txBody>
+      </p:sp>
+      <p:sp>
+        <p:nvSpPr>
+          <p:cNvPr id="16" name="TextBox 15"/>
+          <p:cNvSpPr txBox="1"/>
+          <p:nvPr/>
+        </p:nvSpPr>
+        <p:spPr>
+          <a:xfrm>
+            <a:off x="822960" y="3163824"/>
+            <a:ext cx="2926080" cy="365760"/>
+          </a:xfrm>
+          <a:prstGeom prst="rect">
+            <a:avLst/>
+          </a:prstGeom>
+          <a:noFill/>
+        </p:spPr>
+        <p:txBody>
+          <a:bodyPr wrap="square" anchor="t">
+            <a:noAutofit/>
+          </a:bodyPr>
+          <a:lstStyle/>
+          <a:p>
+            <a:pPr algn="l">
+              <a:lnSpc>
+                <a:spcPct val="100000"/>
+              </a:lnSpc>
+            </a:pPr>
+            <a:r>
+              <a:rPr sz="1400" b="1">
+                <a:solidFill>
+                  <a:srgbClr val="111318"/>
+                </a:solidFill>
+                <a:latin typeface="Arial"/>
+              </a:rPr>
+              <a:t>Base de données</a:t>
+            </a:r>
+          </a:p>
+        </p:txBody>
+      </p:sp>
+      <p:sp>
+        <p:nvSpPr>
+          <p:cNvPr id="17" name="TextBox 16"/>
+          <p:cNvSpPr txBox="1"/>
+          <p:nvPr/>
+        </p:nvSpPr>
+        <p:spPr>
+          <a:xfrm>
+            <a:off x="3931920" y="3163824"/>
+            <a:ext cx="7498079" cy="365760"/>
+          </a:xfrm>
+          <a:prstGeom prst="rect">
+            <a:avLst/>
+          </a:prstGeom>
+          <a:noFill/>
+        </p:spPr>
+        <p:txBody>
+          <a:bodyPr wrap="square" anchor="t">
+            <a:noAutofit/>
+          </a:bodyPr>
+          <a:lstStyle/>
+          <a:p>
+            <a:pPr algn="l">
+              <a:lnSpc>
+                <a:spcPct val="100000"/>
+              </a:lnSpc>
+            </a:pPr>
+            <a:r>
+              <a:rPr sz="1400" b="0">
+                <a:solidFill>
+                  <a:srgbClr val="6B6F76"/>
+                </a:solidFill>
+                <a:latin typeface="Arial"/>
+              </a:rPr>
+              <a:t>PostgreSQL (Cloud SQL)</a:t>
+            </a:r>
+          </a:p>
+        </p:txBody>
+      </p:sp>
+      <p:sp>
+        <p:nvSpPr>
+          <p:cNvPr id="18" name="Rectangle 17"/>
+          <p:cNvSpPr/>
+          <p:nvPr/>
+        </p:nvSpPr>
+        <p:spPr>
+          <a:xfrm>
+            <a:off x="548640" y="3621024"/>
+            <a:ext cx="11064240" cy="566928"/>
+          </a:xfrm>
+          <a:prstGeom prst="rect">
+            <a:avLst/>
+          </a:prstGeom>
+          <a:solidFill>
+            <a:srgbClr val="FFFFFF"/>
+          </a:solidFill>
+          <a:ln>
+            <a:noFill/>
+          </a:ln>
+          <a:effectLst/>
+        </p:spPr>
+        <p:style>
+          <a:lnRef idx="1">
+            <a:schemeClr val="accent1"/>
+          </a:lnRef>
+          <a:fillRef idx="3">
+            <a:schemeClr val="accent1"/>
+          </a:fillRef>
+          <a:effectRef idx="2">
+            <a:schemeClr val="accent1"/>
+          </a:effectRef>
+          <a:fontRef idx="minor">
+            <a:schemeClr val="lt1"/>
+          </a:fontRef>
+        </p:style>
+        <p:txBody>
+          <a:bodyPr rtlCol="0" anchor="ctr"/>
+          <a:lstStyle/>
+          <a:p>
+            <a:pPr algn="ctr"/>
+          </a:p>
+        </p:txBody>
+      </p:sp>
+      <p:sp>
+        <p:nvSpPr>
+          <p:cNvPr id="19" name="TextBox 18"/>
+          <p:cNvSpPr txBox="1"/>
+          <p:nvPr/>
+        </p:nvSpPr>
+        <p:spPr>
+          <a:xfrm>
+            <a:off x="822960" y="3730752"/>
+            <a:ext cx="2926080" cy="365760"/>
+          </a:xfrm>
+          <a:prstGeom prst="rect">
+            <a:avLst/>
+          </a:prstGeom>
+          <a:noFill/>
+        </p:spPr>
+        <p:txBody>
+          <a:bodyPr wrap="square" anchor="t">
+            <a:noAutofit/>
+          </a:bodyPr>
+          <a:lstStyle/>
+          <a:p>
+            <a:pPr algn="l">
+              <a:lnSpc>
+                <a:spcPct val="100000"/>
+              </a:lnSpc>
+            </a:pPr>
+            <a:r>
+              <a:rPr sz="1400" b="1">
+                <a:solidFill>
+                  <a:srgbClr val="111318"/>
+                </a:solidFill>
+                <a:latin typeface="Arial"/>
+              </a:rPr>
+              <a:t>Visioconférence</a:t>
+            </a:r>
+          </a:p>
+        </p:txBody>
+      </p:sp>
+      <p:sp>
+        <p:nvSpPr>
+          <p:cNvPr id="20" name="TextBox 19"/>
+          <p:cNvSpPr txBox="1"/>
+          <p:nvPr/>
+        </p:nvSpPr>
+        <p:spPr>
+          <a:xfrm>
+            <a:off x="3931920" y="3730752"/>
+            <a:ext cx="7498079" cy="365760"/>
+          </a:xfrm>
+          <a:prstGeom prst="rect">
+            <a:avLst/>
+          </a:prstGeom>
+          <a:noFill/>
+        </p:spPr>
+        <p:txBody>
+          <a:bodyPr wrap="square" anchor="t">
+            <a:noAutofit/>
+          </a:bodyPr>
+          <a:lstStyle/>
+          <a:p>
+            <a:pPr algn="l">
+              <a:lnSpc>
+                <a:spcPct val="100000"/>
+              </a:lnSpc>
+            </a:pPr>
+            <a:r>
+              <a:rPr sz="1400" b="0">
+                <a:solidFill>
+                  <a:srgbClr val="6B6F76"/>
+                </a:solidFill>
+                <a:latin typeface="Arial"/>
+              </a:rPr>
+              <a:t>WebRTC (simple-peer) + Socket.IO</a:t>
+            </a:r>
+          </a:p>
+        </p:txBody>
+      </p:sp>
+      <p:sp>
+        <p:nvSpPr>
+          <p:cNvPr id="21" name="Rectangle 20"/>
+          <p:cNvSpPr/>
+          <p:nvPr/>
+        </p:nvSpPr>
+        <p:spPr>
+          <a:xfrm>
+            <a:off x="548640" y="4187952"/>
+            <a:ext cx="11064240" cy="566928"/>
+          </a:xfrm>
+          <a:prstGeom prst="rect">
+            <a:avLst/>
+          </a:prstGeom>
+          <a:solidFill>
+            <a:srgbClr val="F2F3F5"/>
+          </a:solidFill>
+          <a:ln>
+            <a:noFill/>
+          </a:ln>
+          <a:effectLst/>
+        </p:spPr>
+        <p:style>
+          <a:lnRef idx="1">
+            <a:schemeClr val="accent1"/>
+          </a:lnRef>
+          <a:fillRef idx="3">
+            <a:schemeClr val="accent1"/>
+          </a:fillRef>
+          <a:effectRef idx="2">
+            <a:schemeClr val="accent1"/>
+          </a:effectRef>
+          <a:fontRef idx="minor">
+            <a:schemeClr val="lt1"/>
+          </a:fontRef>
+        </p:style>
+        <p:txBody>
+          <a:bodyPr rtlCol="0" anchor="ctr"/>
+          <a:lstStyle/>
+          <a:p>
+            <a:pPr algn="ctr"/>
+          </a:p>
+        </p:txBody>
+      </p:sp>
+      <p:sp>
+        <p:nvSpPr>
+          <p:cNvPr id="22" name="TextBox 21"/>
+          <p:cNvSpPr txBox="1"/>
+          <p:nvPr/>
+        </p:nvSpPr>
+        <p:spPr>
+          <a:xfrm>
+            <a:off x="822960" y="4297680"/>
+            <a:ext cx="2926080" cy="365760"/>
+          </a:xfrm>
+          <a:prstGeom prst="rect">
+            <a:avLst/>
+          </a:prstGeom>
+          <a:noFill/>
+        </p:spPr>
+        <p:txBody>
+          <a:bodyPr wrap="square" anchor="t">
+            <a:noAutofit/>
+          </a:bodyPr>
+          <a:lstStyle/>
+          <a:p>
+            <a:pPr algn="l">
+              <a:lnSpc>
+                <a:spcPct val="100000"/>
+              </a:lnSpc>
+            </a:pPr>
+            <a:r>
+              <a:rPr sz="1400" b="1">
+                <a:solidFill>
+                  <a:srgbClr val="111318"/>
+                </a:solidFill>
+                <a:latin typeface="Arial"/>
+              </a:rPr>
+              <a:t>Cloud</a:t>
+            </a:r>
+          </a:p>
+        </p:txBody>
+      </p:sp>
+      <p:sp>
+        <p:nvSpPr>
+          <p:cNvPr id="23" name="TextBox 22"/>
+          <p:cNvSpPr txBox="1"/>
+          <p:nvPr/>
+        </p:nvSpPr>
+        <p:spPr>
+          <a:xfrm>
+            <a:off x="3931920" y="4297680"/>
+            <a:ext cx="7498079" cy="365760"/>
+          </a:xfrm>
+          <a:prstGeom prst="rect">
+            <a:avLst/>
+          </a:prstGeom>
+          <a:noFill/>
+        </p:spPr>
+        <p:txBody>
+          <a:bodyPr wrap="square" anchor="t">
+            <a:noAutofit/>
+          </a:bodyPr>
+          <a:lstStyle/>
+          <a:p>
+            <a:pPr algn="l">
+              <a:lnSpc>
+                <a:spcPct val="100000"/>
+              </a:lnSpc>
+            </a:pPr>
+            <a:r>
+              <a:rPr sz="1400" b="0">
+                <a:solidFill>
+                  <a:srgbClr val="6B6F76"/>
+                </a:solidFill>
+                <a:latin typeface="Arial"/>
+              </a:rPr>
+              <a:t>Google Cloud Platform (Cloud Run, Cloud SQL)</a:t>
+            </a:r>
+          </a:p>
+        </p:txBody>
+      </p:sp>
+      <p:sp>
+        <p:nvSpPr>
+          <p:cNvPr id="24" name="Rectangle 23"/>
+          <p:cNvSpPr/>
+          <p:nvPr/>
+        </p:nvSpPr>
+        <p:spPr>
+          <a:xfrm>
+            <a:off x="548640" y="4754880"/>
+            <a:ext cx="11064240" cy="566928"/>
+          </a:xfrm>
+          <a:prstGeom prst="rect">
+            <a:avLst/>
+          </a:prstGeom>
+          <a:solidFill>
+            <a:srgbClr val="FFFFFF"/>
+          </a:solidFill>
+          <a:ln>
+            <a:noFill/>
+          </a:ln>
+          <a:effectLst/>
+        </p:spPr>
+        <p:style>
+          <a:lnRef idx="1">
+            <a:schemeClr val="accent1"/>
+          </a:lnRef>
+          <a:fillRef idx="3">
+            <a:schemeClr val="accent1"/>
+          </a:fillRef>
+          <a:effectRef idx="2">
+            <a:schemeClr val="accent1"/>
+          </a:effectRef>
+          <a:fontRef idx="minor">
+            <a:schemeClr val="lt1"/>
+          </a:fontRef>
+        </p:style>
+        <p:txBody>
+          <a:bodyPr rtlCol="0" anchor="ctr"/>
+          <a:lstStyle/>
+          <a:p>
+            <a:pPr algn="ctr"/>
+          </a:p>
+        </p:txBody>
+      </p:sp>
+      <p:sp>
+        <p:nvSpPr>
+          <p:cNvPr id="25" name="TextBox 24"/>
+          <p:cNvSpPr txBox="1"/>
+          <p:nvPr/>
+        </p:nvSpPr>
+        <p:spPr>
+          <a:xfrm>
+            <a:off x="822960" y="4864608"/>
+            <a:ext cx="2926080" cy="365760"/>
+          </a:xfrm>
+          <a:prstGeom prst="rect">
+            <a:avLst/>
+          </a:prstGeom>
+          <a:noFill/>
+        </p:spPr>
+        <p:txBody>
+          <a:bodyPr wrap="square" anchor="t">
+            <a:noAutofit/>
+          </a:bodyPr>
+          <a:lstStyle/>
+          <a:p>
+            <a:pPr algn="l">
+              <a:lnSpc>
+                <a:spcPct val="100000"/>
+              </a:lnSpc>
+            </a:pPr>
+            <a:r>
+              <a:rPr sz="1400" b="1">
+                <a:solidFill>
+                  <a:srgbClr val="111318"/>
+                </a:solidFill>
+                <a:latin typeface="Arial"/>
+              </a:rPr>
+              <a:t>CI/CD</a:t>
+            </a:r>
+          </a:p>
+        </p:txBody>
+      </p:sp>
+      <p:sp>
+        <p:nvSpPr>
+          <p:cNvPr id="26" name="TextBox 25"/>
+          <p:cNvSpPr txBox="1"/>
+          <p:nvPr/>
+        </p:nvSpPr>
+        <p:spPr>
+          <a:xfrm>
+            <a:off x="3931920" y="4864608"/>
+            <a:ext cx="7498079" cy="365760"/>
+          </a:xfrm>
+          <a:prstGeom prst="rect">
+            <a:avLst/>
+          </a:prstGeom>
+          <a:noFill/>
+        </p:spPr>
+        <p:txBody>
+          <a:bodyPr wrap="square" anchor="t">
+            <a:noAutofit/>
+          </a:bodyPr>
+          <a:lstStyle/>
+          <a:p>
+            <a:pPr algn="l">
+              <a:lnSpc>
+                <a:spcPct val="100000"/>
+              </a:lnSpc>
+            </a:pPr>
+            <a:r>
+              <a:rPr sz="1400" b="0">
+                <a:solidFill>
+                  <a:srgbClr val="6B6F76"/>
+                </a:solidFill>
+                <a:latin typeface="Arial"/>
+              </a:rPr>
+              <a:t>GitHub Actions</a:t>
             </a:r>
           </a:p>
         </p:txBody>
@@ -4763,7 +4894,7 @@
             <a:avLst/>
           </a:prstGeom>
           <a:solidFill>
-            <a:srgbClr val="FFFFFF"/>
+            <a:srgbClr val="111318"/>
           </a:solidFill>
           <a:ln>
             <a:noFill/>
@@ -4800,8 +4931,8 @@
         </p:nvSpPr>
         <p:spPr>
           <a:xfrm>
-            <a:off x="548640" y="457200"/>
-            <a:ext cx="2295144" cy="310896"/>
+            <a:off x="-1097280" y="-1097280"/>
+            <a:ext cx="2926080" cy="2926080"/>
           </a:xfrm>
           <a:prstGeom prst="rect">
             <a:avLst/>
@@ -4829,21 +4960,10 @@
           </a:fontRef>
         </p:style>
         <p:txBody>
-          <a:bodyPr rtlCol="0" anchor="ctr" wrap="none" lIns="109728" rIns="109728" tIns="18288" bIns="18288">
-            <a:noAutofit/>
-          </a:bodyPr>
+          <a:bodyPr rtlCol="0" anchor="ctr"/>
           <a:lstStyle/>
           <a:p>
             <a:pPr algn="ctr"/>
-            <a:r>
-              <a:rPr sz="1200" b="1">
-                <a:solidFill>
-                  <a:srgbClr val="111318"/>
-                </a:solidFill>
-                <a:latin typeface="Arial"/>
-              </a:rPr>
-              <a:t>TRANSPARENCE</a:t>
-            </a:r>
           </a:p>
         </p:txBody>
       </p:sp>
@@ -4855,8 +4975,8 @@
         </p:nvSpPr>
         <p:spPr>
           <a:xfrm>
-            <a:off x="530352" y="868680"/>
-            <a:ext cx="10789920" cy="822960"/>
+            <a:off x="822960" y="2743200"/>
+            <a:ext cx="1828800" cy="1097280"/>
           </a:xfrm>
           <a:prstGeom prst="rect">
             <a:avLst/>
@@ -4875,71 +4995,27 @@
               </a:lnSpc>
             </a:pPr>
             <a:r>
-              <a:rPr sz="3000" b="1">
-                <a:solidFill>
-                  <a:srgbClr val="111318"/>
-                </a:solidFill>
-                <a:latin typeface="Arial"/>
-              </a:rPr>
-              <a:t>CE QUI RESTE À FAIRE</a:t>
-            </a:r>
-          </a:p>
-        </p:txBody>
-      </p:sp>
-      <p:sp>
-        <p:nvSpPr>
-          <p:cNvPr id="5" name="Rectangle 4"/>
-          <p:cNvSpPr/>
-          <p:nvPr/>
-        </p:nvSpPr>
-        <p:spPr>
-          <a:xfrm>
-            <a:off x="548640" y="1536192"/>
-            <a:ext cx="11064240" cy="19050"/>
-          </a:xfrm>
-          <a:prstGeom prst="rect">
-            <a:avLst/>
-          </a:prstGeom>
-          <a:solidFill>
-            <a:srgbClr val="111318"/>
-          </a:solidFill>
-          <a:ln>
-            <a:noFill/>
-          </a:ln>
-          <a:effectLst/>
-        </p:spPr>
-        <p:style>
-          <a:lnRef idx="1">
-            <a:schemeClr val="accent1"/>
-          </a:lnRef>
-          <a:fillRef idx="3">
-            <a:schemeClr val="accent1"/>
-          </a:fillRef>
-          <a:effectRef idx="2">
-            <a:schemeClr val="accent1"/>
-          </a:effectRef>
-          <a:fontRef idx="minor">
-            <a:schemeClr val="lt1"/>
-          </a:fontRef>
-        </p:style>
-        <p:txBody>
-          <a:bodyPr rtlCol="0" anchor="ctr"/>
-          <a:lstStyle/>
-          <a:p>
-            <a:pPr algn="ctr"/>
-          </a:p>
-        </p:txBody>
-      </p:sp>
-      <p:sp>
-        <p:nvSpPr>
-          <p:cNvPr id="6" name="TextBox 5"/>
+              <a:rPr sz="7200" b="1">
+                <a:solidFill>
+                  <a:srgbClr val="33353D"/>
+                </a:solidFill>
+                <a:latin typeface="Arial"/>
+              </a:rPr>
+              <a:t>03</a:t>
+            </a:r>
+          </a:p>
+        </p:txBody>
+      </p:sp>
+      <p:sp>
+        <p:nvSpPr>
+          <p:cNvPr id="5" name="TextBox 4"/>
           <p:cNvSpPr txBox="1"/>
           <p:nvPr/>
         </p:nvSpPr>
         <p:spPr>
           <a:xfrm>
-            <a:off x="548640" y="6473952"/>
-            <a:ext cx="3657600" cy="274320"/>
+            <a:off x="822960" y="3566160"/>
+            <a:ext cx="10058400" cy="1097280"/>
           </a:xfrm>
           <a:prstGeom prst="rect">
             <a:avLst/>
@@ -4958,110 +5034,27 @@
               </a:lnSpc>
             </a:pPr>
             <a:r>
-              <a:rPr sz="1000" b="1">
-                <a:solidFill>
-                  <a:srgbClr val="6B6F76"/>
-                </a:solidFill>
-                <a:latin typeface="Arial"/>
-              </a:rPr>
-              <a:t>TECHPAPY</a:t>
-            </a:r>
-          </a:p>
-        </p:txBody>
-      </p:sp>
-      <p:sp>
-        <p:nvSpPr>
-          <p:cNvPr id="7" name="TextBox 6"/>
+              <a:rPr sz="4000" b="1">
+                <a:solidFill>
+                  <a:srgbClr val="FFFFFF"/>
+                </a:solidFill>
+                <a:latin typeface="Arial"/>
+              </a:rPr>
+              <a:t>BILAN DU PROJET</a:t>
+            </a:r>
+          </a:p>
+        </p:txBody>
+      </p:sp>
+      <p:sp>
+        <p:nvSpPr>
+          <p:cNvPr id="6" name="TextBox 5"/>
           <p:cNvSpPr txBox="1"/>
           <p:nvPr/>
         </p:nvSpPr>
         <p:spPr>
           <a:xfrm>
-            <a:off x="11155680" y="6473952"/>
-            <a:ext cx="548640" cy="274320"/>
-          </a:xfrm>
-          <a:prstGeom prst="rect">
-            <a:avLst/>
-          </a:prstGeom>
-          <a:noFill/>
-        </p:spPr>
-        <p:txBody>
-          <a:bodyPr wrap="square" anchor="t">
-            <a:noAutofit/>
-          </a:bodyPr>
-          <a:lstStyle/>
-          <a:p>
-            <a:pPr algn="r">
-              <a:lnSpc>
-                <a:spcPct val="100000"/>
-              </a:lnSpc>
-            </a:pPr>
-            <a:r>
-              <a:rPr sz="1000" b="1">
-                <a:solidFill>
-                  <a:srgbClr val="6B6F76"/>
-                </a:solidFill>
-                <a:latin typeface="Arial"/>
-              </a:rPr>
-              <a:t>12</a:t>
-            </a:r>
-          </a:p>
-        </p:txBody>
-      </p:sp>
-      <p:sp>
-        <p:nvSpPr>
-          <p:cNvPr id="8" name="Rectangle 7"/>
-          <p:cNvSpPr/>
-          <p:nvPr/>
-        </p:nvSpPr>
-        <p:spPr>
-          <a:xfrm>
-            <a:off x="548640" y="6419088"/>
-            <a:ext cx="11064240" cy="12700"/>
-          </a:xfrm>
-          <a:prstGeom prst="rect">
-            <a:avLst/>
-          </a:prstGeom>
-          <a:solidFill>
-            <a:srgbClr val="D8DADF"/>
-          </a:solidFill>
-          <a:ln>
-            <a:noFill/>
-          </a:ln>
-          <a:effectLst/>
-        </p:spPr>
-        <p:style>
-          <a:lnRef idx="1">
-            <a:schemeClr val="accent1"/>
-          </a:lnRef>
-          <a:fillRef idx="3">
-            <a:schemeClr val="accent1"/>
-          </a:fillRef>
-          <a:effectRef idx="2">
-            <a:schemeClr val="accent1"/>
-          </a:effectRef>
-          <a:fontRef idx="minor">
-            <a:schemeClr val="lt1"/>
-          </a:fontRef>
-        </p:style>
-        <p:txBody>
-          <a:bodyPr rtlCol="0" anchor="ctr"/>
-          <a:lstStyle/>
-          <a:p>
-            <a:pPr algn="ctr"/>
-          </a:p>
-        </p:txBody>
-      </p:sp>
-      <p:sp>
-        <p:nvSpPr>
-          <p:cNvPr id="9" name="TextBox 8"/>
-          <p:cNvSpPr txBox="1"/>
-          <p:nvPr/>
-        </p:nvSpPr>
-        <p:spPr>
-          <a:xfrm>
-            <a:off x="548640" y="1828800"/>
-            <a:ext cx="5303520" cy="365760"/>
+            <a:off x="841248" y="4343400"/>
+            <a:ext cx="9144000" cy="548640"/>
           </a:xfrm>
           <a:prstGeom prst="rect">
             <a:avLst/>
@@ -5080,223 +5073,13 @@
               </a:lnSpc>
             </a:pPr>
             <a:r>
-              <a:rPr sz="1300" b="1">
+              <a:rPr sz="1500" b="0">
                 <a:solidFill>
                   <a:srgbClr val="6B6F76"/>
                 </a:solidFill>
                 <a:latin typeface="Arial"/>
               </a:rPr>
-              <a:t>EN COURS</a:t>
-            </a:r>
-          </a:p>
-        </p:txBody>
-      </p:sp>
-      <p:sp>
-        <p:nvSpPr>
-          <p:cNvPr id="10" name="TextBox 9"/>
-          <p:cNvSpPr txBox="1"/>
-          <p:nvPr/>
-        </p:nvSpPr>
-        <p:spPr>
-          <a:xfrm>
-            <a:off x="548640" y="2240280"/>
-            <a:ext cx="5303520" cy="3657600"/>
-          </a:xfrm>
-          <a:prstGeom prst="rect">
-            <a:avLst/>
-          </a:prstGeom>
-          <a:noFill/>
-        </p:spPr>
-        <p:txBody>
-          <a:bodyPr wrap="square">
-            <a:noAutofit/>
-          </a:bodyPr>
-          <a:lstStyle/>
-          <a:p>
-            <a:pPr>
-              <a:spcAft>
-                <a:spcPts val="1000"/>
-              </a:spcAft>
-            </a:pPr>
-            <a:r>
-              <a:rPr sz="1450">
-                <a:solidFill>
-                  <a:srgbClr val="FFC700"/>
-                </a:solidFill>
-                <a:latin typeface="Arial"/>
-              </a:rPr>
-              <a:t>■  </a:t>
-            </a:r>
-            <a:r>
-              <a:rPr sz="1450">
-                <a:solidFill>
-                  <a:srgbClr val="111318"/>
-                </a:solidFill>
-                <a:latin typeface="Arial"/>
-              </a:rPr>
-              <a:t>Validation du CI/CD automatisé (secrets GitHub)</a:t>
-            </a:r>
-          </a:p>
-          <a:p>
-            <a:pPr>
-              <a:spcAft>
-                <a:spcPts val="1000"/>
-              </a:spcAft>
-            </a:pPr>
-            <a:r>
-              <a:rPr sz="1450">
-                <a:solidFill>
-                  <a:srgbClr val="FFC700"/>
-                </a:solidFill>
-                <a:latin typeface="Arial"/>
-              </a:rPr>
-              <a:t>■  </a:t>
-            </a:r>
-            <a:r>
-              <a:rPr sz="1450">
-                <a:solidFill>
-                  <a:srgbClr val="111318"/>
-                </a:solidFill>
-                <a:latin typeface="Arial"/>
-              </a:rPr>
-              <a:t>Déploiement de la VM de monitoring</a:t>
-            </a:r>
-          </a:p>
-          <a:p>
-            <a:pPr>
-              <a:spcAft>
-                <a:spcPts val="1000"/>
-              </a:spcAft>
-            </a:pPr>
-            <a:r>
-              <a:rPr sz="1450">
-                <a:solidFill>
-                  <a:srgbClr val="FFC700"/>
-                </a:solidFill>
-                <a:latin typeface="Arial"/>
-              </a:rPr>
-              <a:t>■  </a:t>
-            </a:r>
-            <a:r>
-              <a:rPr sz="1450">
-                <a:solidFill>
-                  <a:srgbClr val="111318"/>
-                </a:solidFill>
-                <a:latin typeface="Arial"/>
-              </a:rPr>
-              <a:t>Certificat HTTPS du domaine (propagation DNS)</a:t>
-            </a:r>
-          </a:p>
-        </p:txBody>
-      </p:sp>
-      <p:sp>
-        <p:nvSpPr>
-          <p:cNvPr id="11" name="TextBox 10"/>
-          <p:cNvSpPr txBox="1"/>
-          <p:nvPr/>
-        </p:nvSpPr>
-        <p:spPr>
-          <a:xfrm>
-            <a:off x="6309360" y="1828800"/>
-            <a:ext cx="5303520" cy="365760"/>
-          </a:xfrm>
-          <a:prstGeom prst="rect">
-            <a:avLst/>
-          </a:prstGeom>
-          <a:noFill/>
-        </p:spPr>
-        <p:txBody>
-          <a:bodyPr wrap="square" anchor="t">
-            <a:noAutofit/>
-          </a:bodyPr>
-          <a:lstStyle/>
-          <a:p>
-            <a:pPr algn="l">
-              <a:lnSpc>
-                <a:spcPct val="100000"/>
-              </a:lnSpc>
-            </a:pPr>
-            <a:r>
-              <a:rPr sz="1300" b="1">
-                <a:solidFill>
-                  <a:srgbClr val="6B6F76"/>
-                </a:solidFill>
-                <a:latin typeface="Arial"/>
-              </a:rPr>
-              <a:t>NON FAIT</a:t>
-            </a:r>
-          </a:p>
-        </p:txBody>
-      </p:sp>
-      <p:sp>
-        <p:nvSpPr>
-          <p:cNvPr id="12" name="TextBox 11"/>
-          <p:cNvSpPr txBox="1"/>
-          <p:nvPr/>
-        </p:nvSpPr>
-        <p:spPr>
-          <a:xfrm>
-            <a:off x="6309360" y="2240280"/>
-            <a:ext cx="5303520" cy="3657600"/>
-          </a:xfrm>
-          <a:prstGeom prst="rect">
-            <a:avLst/>
-          </a:prstGeom>
-          <a:noFill/>
-        </p:spPr>
-        <p:txBody>
-          <a:bodyPr wrap="square">
-            <a:noAutofit/>
-          </a:bodyPr>
-          <a:lstStyle/>
-          <a:p>
-            <a:pPr>
-              <a:spcAft>
-                <a:spcPts val="1000"/>
-              </a:spcAft>
-            </a:pPr>
-            <a:r>
-              <a:rPr sz="1450">
-                <a:solidFill>
-                  <a:srgbClr val="FFC700"/>
-                </a:solidFill>
-                <a:latin typeface="Arial"/>
-              </a:rPr>
-              <a:t>■  </a:t>
-            </a:r>
-            <a:r>
-              <a:rPr sz="1450">
-                <a:solidFill>
-                  <a:srgbClr val="111318"/>
-                </a:solidFill>
-                <a:latin typeface="Arial"/>
-              </a:rPr>
-              <a:t>Kubernetes (recommandé, pas obligatoire)</a:t>
-            </a:r>
-          </a:p>
-          <a:p>
-            <a:pPr>
-              <a:spcAft>
-                <a:spcPts val="1000"/>
-              </a:spcAft>
-            </a:pPr>
-            <a:r>
-              <a:rPr sz="1450">
-                <a:solidFill>
-                  <a:srgbClr val="FFC700"/>
-                </a:solidFill>
-                <a:latin typeface="Arial"/>
-              </a:rPr>
-              <a:t>■  </a:t>
-            </a:r>
-            <a:r>
-              <a:rPr sz="1450">
-                <a:solidFill>
-                  <a:srgbClr val="111318"/>
-                </a:solidFill>
-                <a:latin typeface="Arial"/>
-              </a:rPr>
-              <a:t>Attribution manuelle des rôles de modération avancée</a:t>
+              <a:t>Ce qui est fait, ce qui reste</a:t>
             </a:r>
           </a:p>
         </p:txBody>
@@ -5413,7 +5196,7 @@
                 </a:solidFill>
                 <a:latin typeface="Arial"/>
               </a:rPr>
-              <a:t>MÉTHODOLOGIE</a:t>
+              <a:t>TRANSPARENCE</a:t>
             </a:r>
           </a:p>
         </p:txBody>
@@ -5452,7 +5235,7 @@
                 </a:solidFill>
                 <a:latin typeface="Arial"/>
               </a:rPr>
-              <a:t>USAGE DE L'INTELLIGENCE ARTIFICIELLE</a:t>
+              <a:t>CE QUI RESTE À FAIRE</a:t>
             </a:r>
           </a:p>
         </p:txBody>
@@ -5631,8 +5414,8 @@
         </p:nvSpPr>
         <p:spPr>
           <a:xfrm>
-            <a:off x="548640" y="1920240"/>
-            <a:ext cx="10881360" cy="2011680"/>
+            <a:off x="548640" y="1828800"/>
+            <a:ext cx="5303520" cy="365760"/>
           </a:xfrm>
           <a:prstGeom prst="rect">
             <a:avLst/>
@@ -5647,62 +5430,116 @@
           <a:p>
             <a:pPr algn="l">
               <a:lnSpc>
-                <a:spcPct val="130000"/>
+                <a:spcPct val="100000"/>
               </a:lnSpc>
             </a:pPr>
             <a:r>
-              <a:rPr sz="1700" b="0">
+              <a:rPr sz="1300" b="1">
+                <a:solidFill>
+                  <a:srgbClr val="6B6F76"/>
+                </a:solidFill>
+                <a:latin typeface="Arial"/>
+              </a:rPr>
+              <a:t>EN COURS</a:t>
+            </a:r>
+          </a:p>
+        </p:txBody>
+      </p:sp>
+      <p:sp>
+        <p:nvSpPr>
+          <p:cNvPr id="10" name="TextBox 9"/>
+          <p:cNvSpPr txBox="1"/>
+          <p:nvPr/>
+        </p:nvSpPr>
+        <p:spPr>
+          <a:xfrm>
+            <a:off x="548640" y="2240280"/>
+            <a:ext cx="5303520" cy="3657600"/>
+          </a:xfrm>
+          <a:prstGeom prst="rect">
+            <a:avLst/>
+          </a:prstGeom>
+          <a:noFill/>
+        </p:spPr>
+        <p:txBody>
+          <a:bodyPr wrap="square">
+            <a:noAutofit/>
+          </a:bodyPr>
+          <a:lstStyle/>
+          <a:p>
+            <a:pPr>
+              <a:spcAft>
+                <a:spcPts val="1000"/>
+              </a:spcAft>
+            </a:pPr>
+            <a:r>
+              <a:rPr sz="1450">
+                <a:solidFill>
+                  <a:srgbClr val="FFC700"/>
+                </a:solidFill>
+                <a:latin typeface="Arial"/>
+              </a:rPr>
+              <a:t>■  </a:t>
+            </a:r>
+            <a:r>
+              <a:rPr sz="1450">
                 <a:solidFill>
                   <a:srgbClr val="111318"/>
                 </a:solidFill>
                 <a:latin typeface="Arial"/>
               </a:rPr>
-              <a:t>Ce projet a été développé avec l'assistance de Claude (Claude Code, Anthropic), utilisé pour générer le squelette du code, implémenter les fonctionnalités, déboguer et documenter le projet.</a:t>
-            </a:r>
-          </a:p>
-        </p:txBody>
-      </p:sp>
-      <p:sp>
-        <p:nvSpPr>
-          <p:cNvPr id="10" name="Rectangle 9"/>
-          <p:cNvSpPr/>
-          <p:nvPr/>
-        </p:nvSpPr>
-        <p:spPr>
-          <a:xfrm>
-            <a:off x="548640" y="3931920"/>
-            <a:ext cx="10881360" cy="12700"/>
-          </a:xfrm>
-          <a:prstGeom prst="rect">
-            <a:avLst/>
-          </a:prstGeom>
-          <a:solidFill>
-            <a:srgbClr val="D8DADF"/>
-          </a:solidFill>
-          <a:ln>
-            <a:noFill/>
-          </a:ln>
-          <a:effectLst/>
-        </p:spPr>
-        <p:style>
-          <a:lnRef idx="1">
-            <a:schemeClr val="accent1"/>
-          </a:lnRef>
-          <a:fillRef idx="3">
-            <a:schemeClr val="accent1"/>
-          </a:fillRef>
-          <a:effectRef idx="2">
-            <a:schemeClr val="accent1"/>
-          </a:effectRef>
-          <a:fontRef idx="minor">
-            <a:schemeClr val="lt1"/>
-          </a:fontRef>
-        </p:style>
-        <p:txBody>
-          <a:bodyPr rtlCol="0" anchor="ctr"/>
-          <a:lstStyle/>
-          <a:p>
-            <a:pPr algn="ctr"/>
+              <a:t>Validation du CI/CD automatisé (secrets GitHub)</a:t>
+            </a:r>
+          </a:p>
+          <a:p>
+            <a:pPr>
+              <a:spcAft>
+                <a:spcPts val="1000"/>
+              </a:spcAft>
+            </a:pPr>
+            <a:r>
+              <a:rPr sz="1450">
+                <a:solidFill>
+                  <a:srgbClr val="FFC700"/>
+                </a:solidFill>
+                <a:latin typeface="Arial"/>
+              </a:rPr>
+              <a:t>■  </a:t>
+            </a:r>
+            <a:r>
+              <a:rPr sz="1450">
+                <a:solidFill>
+                  <a:srgbClr val="111318"/>
+                </a:solidFill>
+                <a:latin typeface="Arial"/>
+              </a:rPr>
+              <a:t>Déploiement de la VM de monitoring</a:t>
+            </a:r>
+          </a:p>
+          <a:p>
+            <a:pPr>
+              <a:spcAft>
+                <a:spcPts val="1000"/>
+              </a:spcAft>
+            </a:pPr>
+            <a:r>
+              <a:rPr sz="1450">
+                <a:solidFill>
+                  <a:srgbClr val="FFC700"/>
+                </a:solidFill>
+                <a:latin typeface="Arial"/>
+              </a:rPr>
+              <a:t>■  </a:t>
+            </a:r>
+            <a:r>
+              <a:rPr sz="1450">
+                <a:solidFill>
+                  <a:srgbClr val="111318"/>
+                </a:solidFill>
+                <a:latin typeface="Arial"/>
+              </a:rPr>
+              <a:t>Certificat HTTPS du domaine (propagation DNS)</a:t>
+            </a:r>
           </a:p>
         </p:txBody>
       </p:sp>
@@ -5714,8 +5551,8 @@
         </p:nvSpPr>
         <p:spPr>
           <a:xfrm>
-            <a:off x="548640" y="4160520"/>
-            <a:ext cx="10881360" cy="1645920"/>
+            <a:off x="6309360" y="1828800"/>
+            <a:ext cx="5303520" cy="365760"/>
           </a:xfrm>
           <a:prstGeom prst="rect">
             <a:avLst/>
@@ -5730,17 +5567,90 @@
           <a:p>
             <a:pPr algn="l">
               <a:lnSpc>
-                <a:spcPct val="130000"/>
+                <a:spcPct val="100000"/>
               </a:lnSpc>
             </a:pPr>
             <a:r>
-              <a:rPr sz="1500" b="0">
+              <a:rPr sz="1300" b="1">
                 <a:solidFill>
                   <a:srgbClr val="6B6F76"/>
                 </a:solidFill>
                 <a:latin typeface="Arial"/>
               </a:rPr>
-              <a:t>La conception fonctionnelle, les choix de priorités, les tests manuels et la validation de chaque étape ont été réalisés directement, avec une compréhension complète de chaque partie du projet.</a:t>
+              <a:t>NON FAIT</a:t>
+            </a:r>
+          </a:p>
+        </p:txBody>
+      </p:sp>
+      <p:sp>
+        <p:nvSpPr>
+          <p:cNvPr id="12" name="TextBox 11"/>
+          <p:cNvSpPr txBox="1"/>
+          <p:nvPr/>
+        </p:nvSpPr>
+        <p:spPr>
+          <a:xfrm>
+            <a:off x="6309360" y="2240280"/>
+            <a:ext cx="5303520" cy="3657600"/>
+          </a:xfrm>
+          <a:prstGeom prst="rect">
+            <a:avLst/>
+          </a:prstGeom>
+          <a:noFill/>
+        </p:spPr>
+        <p:txBody>
+          <a:bodyPr wrap="square">
+            <a:noAutofit/>
+          </a:bodyPr>
+          <a:lstStyle/>
+          <a:p>
+            <a:pPr>
+              <a:spcAft>
+                <a:spcPts val="1000"/>
+              </a:spcAft>
+            </a:pPr>
+            <a:r>
+              <a:rPr sz="1450">
+                <a:solidFill>
+                  <a:srgbClr val="FFC700"/>
+                </a:solidFill>
+                <a:latin typeface="Arial"/>
+              </a:rPr>
+              <a:t>■  </a:t>
+            </a:r>
+            <a:r>
+              <a:rPr sz="1450">
+                <a:solidFill>
+                  <a:srgbClr val="111318"/>
+                </a:solidFill>
+                <a:latin typeface="Arial"/>
+              </a:rPr>
+              <a:t>Kubernetes (recommandé, pas obligatoire)</a:t>
+            </a:r>
+          </a:p>
+          <a:p>
+            <a:pPr>
+              <a:spcAft>
+                <a:spcPts val="1000"/>
+              </a:spcAft>
+            </a:pPr>
+            <a:r>
+              <a:rPr sz="1450">
+                <a:solidFill>
+                  <a:srgbClr val="FFC700"/>
+                </a:solidFill>
+                <a:latin typeface="Arial"/>
+              </a:rPr>
+              <a:t>■  </a:t>
+            </a:r>
+            <a:r>
+              <a:rPr sz="1450">
+                <a:solidFill>
+                  <a:srgbClr val="111318"/>
+                </a:solidFill>
+                <a:latin typeface="Arial"/>
+              </a:rPr>
+              <a:t>Attribution manuelle des rôles de modération avancée</a:t>
             </a:r>
           </a:p>
         </p:txBody>
@@ -5963,7 +5873,7 @@
                 </a:solidFill>
                 <a:latin typeface="Arial"/>
               </a:rPr>
-              <a:t>techpapy.fr  ·  github.com/Aminezy/techpapy-</a:t>
+              <a:t>techpapy.fr  ·  github.com/wiameazim/Techpapy_v1</a:t>
             </a:r>
           </a:p>
         </p:txBody>

</xml_diff>

<commit_message>
Document the admin panel and the cross-site cookie fix
Adds a "Panneau d'administration" section to the technical doc and a
matching slide to the presentation, plus deployment notes about
API_PROXY_TARGET and why /api/* is proxied through the frontend origin.
</commit_message>
<xml_diff>
--- a/TechPapy_Presentation.pptx
+++ b/TechPapy_Presentation.pptx
@@ -15,6 +15,7 @@
     <p:sldId id="263" r:id="rId14"/>
     <p:sldId id="264" r:id="rId15"/>
     <p:sldId id="270" r:id="rId21"/>
+    <p:sldId id="271" r:id="rId19"/>
     <p:sldId id="265" r:id="rId16"/>
     <p:sldId id="266" r:id="rId17"/>
     <p:sldId id="267" r:id="rId18"/>
@@ -4080,7 +4081,7 @@
                 </a:solidFill>
                 <a:latin typeface="Arial"/>
               </a:rPr>
-              <a:t>11</a:t>
+              <a:t>12</a:t>
             </a:r>
           </a:p>
         </p:txBody>
@@ -5357,7 +5358,7 @@
                 </a:solidFill>
                 <a:latin typeface="Arial"/>
               </a:rPr>
-              <a:t>13</a:t>
+              <a:t>14</a:t>
             </a:r>
           </a:p>
         </p:txBody>
@@ -5874,6 +5875,600 @@
                 <a:latin typeface="Arial"/>
               </a:rPr>
               <a:t>techpapy.fr  ·  github.com/wiameazim/Techpapy_v1</a:t>
+            </a:r>
+          </a:p>
+        </p:txBody>
+      </p:sp>
+    </p:spTree>
+  </p:cSld>
+  <p:clrMapOvr>
+    <a:masterClrMapping/>
+  </p:clrMapOvr>
+</p:sld>
+</file>
+
+<file path=ppt/slides/slide15.xml><?xml version="1.0" encoding="utf-8"?>
+<p:sld xmlns:a="http://schemas.openxmlformats.org/drawingml/2006/main" xmlns:p="http://schemas.openxmlformats.org/presentationml/2006/main" xmlns:r="http://schemas.openxmlformats.org/officeDocument/2006/relationships">
+  <p:cSld>
+    <p:spTree>
+      <p:nvGrpSpPr>
+        <p:cNvPr id="1" name=""/>
+        <p:cNvGrpSpPr/>
+        <p:nvPr/>
+      </p:nvGrpSpPr>
+      <p:grpSpPr/>
+      <p:sp>
+        <p:nvSpPr>
+          <p:cNvPr id="2" name="Rectangle 1"/>
+          <p:cNvSpPr/>
+          <p:nvPr/>
+        </p:nvSpPr>
+        <p:spPr>
+          <a:xfrm>
+            <a:off x="0" y="0"/>
+            <a:ext cx="12191695" cy="6858000"/>
+          </a:xfrm>
+          <a:prstGeom prst="rect">
+            <a:avLst/>
+          </a:prstGeom>
+          <a:solidFill>
+            <a:srgbClr val="FFFFFF"/>
+          </a:solidFill>
+          <a:ln>
+            <a:noFill/>
+          </a:ln>
+          <a:effectLst/>
+        </p:spPr>
+        <p:style>
+          <a:lnRef idx="1">
+            <a:schemeClr val="accent1"/>
+          </a:lnRef>
+          <a:fillRef idx="3">
+            <a:schemeClr val="accent1"/>
+          </a:fillRef>
+          <a:effectRef idx="2">
+            <a:schemeClr val="accent1"/>
+          </a:effectRef>
+          <a:fontRef idx="minor">
+            <a:schemeClr val="lt1"/>
+          </a:fontRef>
+        </p:style>
+        <p:txBody>
+          <a:bodyPr rtlCol="0" anchor="ctr"/>
+          <a:lstStyle/>
+          <a:p>
+            <a:pPr algn="ctr"/>
+          </a:p>
+        </p:txBody>
+      </p:sp>
+      <p:sp>
+        <p:nvSpPr>
+          <p:cNvPr id="3" name="Rectangle 2"/>
+          <p:cNvSpPr/>
+          <p:nvPr/>
+        </p:nvSpPr>
+        <p:spPr>
+          <a:xfrm>
+            <a:off x="548640" y="457200"/>
+            <a:ext cx="2971800" cy="310896"/>
+          </a:xfrm>
+          <a:prstGeom prst="rect">
+            <a:avLst/>
+          </a:prstGeom>
+          <a:solidFill>
+            <a:srgbClr val="FFC700"/>
+          </a:solidFill>
+          <a:ln>
+            <a:noFill/>
+          </a:ln>
+          <a:effectLst/>
+        </p:spPr>
+        <p:style>
+          <a:lnRef idx="1">
+            <a:schemeClr val="accent1"/>
+          </a:lnRef>
+          <a:fillRef idx="3">
+            <a:schemeClr val="accent1"/>
+          </a:fillRef>
+          <a:effectRef idx="2">
+            <a:schemeClr val="accent1"/>
+          </a:effectRef>
+          <a:fontRef idx="minor">
+            <a:schemeClr val="lt1"/>
+          </a:fontRef>
+        </p:style>
+        <p:txBody>
+          <a:bodyPr rtlCol="0" anchor="ctr"/>
+          <a:lstStyle/>
+          <a:p>
+            <a:pPr algn="ctr"/>
+          </a:p>
+        </p:txBody>
+      </p:sp>
+      <p:sp>
+        <p:nvSpPr>
+          <p:cNvPr id="4" name="TextBox 3"/>
+          <p:cNvSpPr txBox="1"/>
+          <p:nvPr/>
+        </p:nvSpPr>
+        <p:spPr>
+          <a:xfrm>
+            <a:off x="548640" y="457200"/>
+            <a:ext cx="2971800" cy="310896"/>
+          </a:xfrm>
+          <a:prstGeom prst="rect">
+            <a:avLst/>
+          </a:prstGeom>
+          <a:noFill/>
+        </p:spPr>
+        <p:txBody>
+          <a:bodyPr wrap="square">
+            <a:spAutoFit/>
+          </a:bodyPr>
+          <a:lstStyle/>
+          <a:p>
+            <a:pPr algn="ctr"/>
+            <a:r>
+              <a:rPr sz="1300" b="1">
+                <a:solidFill>
+                  <a:srgbClr val="111318"/>
+                </a:solidFill>
+              </a:rPr>
+              <a:t>ADMINISTRATION</a:t>
+            </a:r>
+          </a:p>
+        </p:txBody>
+      </p:sp>
+      <p:sp>
+        <p:nvSpPr>
+          <p:cNvPr id="5" name="TextBox 4"/>
+          <p:cNvSpPr txBox="1"/>
+          <p:nvPr/>
+        </p:nvSpPr>
+        <p:spPr>
+          <a:xfrm>
+            <a:off x="530352" y="868680"/>
+            <a:ext cx="10789920" cy="822960"/>
+          </a:xfrm>
+          <a:prstGeom prst="rect">
+            <a:avLst/>
+          </a:prstGeom>
+          <a:noFill/>
+        </p:spPr>
+        <p:txBody>
+          <a:bodyPr wrap="square">
+            <a:spAutoFit/>
+          </a:bodyPr>
+          <a:lstStyle/>
+          <a:p>
+            <a:pPr algn="l"/>
+            <a:r>
+              <a:rPr sz="2800" b="1">
+                <a:solidFill>
+                  <a:srgbClr val="111318"/>
+                </a:solidFill>
+              </a:rPr>
+              <a:t>MONITORING &amp; GESTION COMPLÈTE</a:t>
+            </a:r>
+          </a:p>
+        </p:txBody>
+      </p:sp>
+      <p:sp>
+        <p:nvSpPr>
+          <p:cNvPr id="6" name="Rectangle 5"/>
+          <p:cNvSpPr/>
+          <p:nvPr/>
+        </p:nvSpPr>
+        <p:spPr>
+          <a:xfrm>
+            <a:off x="548640" y="1536192"/>
+            <a:ext cx="11064240" cy="19050"/>
+          </a:xfrm>
+          <a:prstGeom prst="rect">
+            <a:avLst/>
+          </a:prstGeom>
+          <a:solidFill>
+            <a:srgbClr val="D8DADF"/>
+          </a:solidFill>
+          <a:ln>
+            <a:noFill/>
+          </a:ln>
+          <a:effectLst/>
+        </p:spPr>
+        <p:style>
+          <a:lnRef idx="1">
+            <a:schemeClr val="accent1"/>
+          </a:lnRef>
+          <a:fillRef idx="3">
+            <a:schemeClr val="accent1"/>
+          </a:fillRef>
+          <a:effectRef idx="2">
+            <a:schemeClr val="accent1"/>
+          </a:effectRef>
+          <a:fontRef idx="minor">
+            <a:schemeClr val="lt1"/>
+          </a:fontRef>
+        </p:style>
+        <p:txBody>
+          <a:bodyPr rtlCol="0" anchor="ctr"/>
+          <a:lstStyle/>
+          <a:p>
+            <a:pPr algn="ctr"/>
+          </a:p>
+        </p:txBody>
+      </p:sp>
+      <p:sp>
+        <p:nvSpPr>
+          <p:cNvPr id="7" name="TextBox 6"/>
+          <p:cNvSpPr txBox="1"/>
+          <p:nvPr/>
+        </p:nvSpPr>
+        <p:spPr>
+          <a:xfrm>
+            <a:off x="548640" y="6473952"/>
+            <a:ext cx="3657600" cy="274320"/>
+          </a:xfrm>
+          <a:prstGeom prst="rect">
+            <a:avLst/>
+          </a:prstGeom>
+          <a:noFill/>
+        </p:spPr>
+        <p:txBody>
+          <a:bodyPr wrap="square">
+            <a:spAutoFit/>
+          </a:bodyPr>
+          <a:lstStyle/>
+          <a:p>
+            <a:pPr algn="l"/>
+            <a:r>
+              <a:rPr sz="1100" b="1">
+                <a:solidFill>
+                  <a:srgbClr val="111318"/>
+                </a:solidFill>
+              </a:rPr>
+              <a:t>TECHPAPY</a:t>
+            </a:r>
+          </a:p>
+        </p:txBody>
+      </p:sp>
+      <p:sp>
+        <p:nvSpPr>
+          <p:cNvPr id="8" name="TextBox 7"/>
+          <p:cNvSpPr txBox="1"/>
+          <p:nvPr/>
+        </p:nvSpPr>
+        <p:spPr>
+          <a:xfrm>
+            <a:off x="11155680" y="6473952"/>
+            <a:ext cx="548640" cy="274320"/>
+          </a:xfrm>
+          <a:prstGeom prst="rect">
+            <a:avLst/>
+          </a:prstGeom>
+          <a:noFill/>
+        </p:spPr>
+        <p:txBody>
+          <a:bodyPr wrap="square">
+            <a:spAutoFit/>
+          </a:bodyPr>
+          <a:lstStyle/>
+          <a:p>
+            <a:pPr algn="r"/>
+            <a:r>
+              <a:rPr sz="1100" b="1">
+                <a:solidFill>
+                  <a:srgbClr val="111318"/>
+                </a:solidFill>
+              </a:rPr>
+              <a:t>11</a:t>
+            </a:r>
+          </a:p>
+        </p:txBody>
+      </p:sp>
+      <p:sp>
+        <p:nvSpPr>
+          <p:cNvPr id="9" name="Rectangle 8"/>
+          <p:cNvSpPr/>
+          <p:nvPr/>
+        </p:nvSpPr>
+        <p:spPr>
+          <a:xfrm>
+            <a:off x="548640" y="6419088"/>
+            <a:ext cx="11064240" cy="12700"/>
+          </a:xfrm>
+          <a:prstGeom prst="rect">
+            <a:avLst/>
+          </a:prstGeom>
+          <a:solidFill>
+            <a:srgbClr val="D8DADF"/>
+          </a:solidFill>
+          <a:ln>
+            <a:noFill/>
+          </a:ln>
+          <a:effectLst/>
+        </p:spPr>
+        <p:style>
+          <a:lnRef idx="1">
+            <a:schemeClr val="accent1"/>
+          </a:lnRef>
+          <a:fillRef idx="3">
+            <a:schemeClr val="accent1"/>
+          </a:fillRef>
+          <a:effectRef idx="2">
+            <a:schemeClr val="accent1"/>
+          </a:effectRef>
+          <a:fontRef idx="minor">
+            <a:schemeClr val="lt1"/>
+          </a:fontRef>
+        </p:style>
+        <p:txBody>
+          <a:bodyPr rtlCol="0" anchor="ctr"/>
+          <a:lstStyle/>
+          <a:p>
+            <a:pPr algn="ctr"/>
+          </a:p>
+        </p:txBody>
+      </p:sp>
+      <p:sp>
+        <p:nvSpPr>
+          <p:cNvPr id="10" name="TextBox 9"/>
+          <p:cNvSpPr txBox="1"/>
+          <p:nvPr/>
+        </p:nvSpPr>
+        <p:spPr>
+          <a:xfrm>
+            <a:off x="548640" y="1828800"/>
+            <a:ext cx="5303520" cy="365760"/>
+          </a:xfrm>
+          <a:prstGeom prst="rect">
+            <a:avLst/>
+          </a:prstGeom>
+          <a:noFill/>
+        </p:spPr>
+        <p:txBody>
+          <a:bodyPr wrap="square">
+            <a:spAutoFit/>
+          </a:bodyPr>
+          <a:lstStyle/>
+          <a:p>
+            <a:pPr algn="l"/>
+            <a:r>
+              <a:rPr sz="1500" b="1">
+                <a:solidFill>
+                  <a:srgbClr val="111318"/>
+                </a:solidFill>
+              </a:rPr>
+              <a:t>VUE D'ENSEMBLE</a:t>
+            </a:r>
+          </a:p>
+        </p:txBody>
+      </p:sp>
+      <p:sp>
+        <p:nvSpPr>
+          <p:cNvPr id="11" name="TextBox 10"/>
+          <p:cNvSpPr txBox="1"/>
+          <p:nvPr/>
+        </p:nvSpPr>
+        <p:spPr>
+          <a:xfrm>
+            <a:off x="548640" y="2240280"/>
+            <a:ext cx="5303520" cy="3657600"/>
+          </a:xfrm>
+          <a:prstGeom prst="rect">
+            <a:avLst/>
+          </a:prstGeom>
+          <a:noFill/>
+        </p:spPr>
+        <p:txBody>
+          <a:bodyPr wrap="square">
+            <a:spAutoFit/>
+          </a:bodyPr>
+          <a:lstStyle/>
+          <a:p>
+            <a:pPr>
+              <a:spcAft>
+                <a:spcPts val="1000"/>
+              </a:spcAft>
+            </a:pPr>
+            <a:r>
+              <a:rPr sz="1300">
+                <a:solidFill>
+                  <a:srgbClr val="111318"/>
+                </a:solidFill>
+              </a:rPr>
+              <a:t>■  Statistiques clés : utilisateurs, compétences, matchs et</a:t>
+            </a:r>
+          </a:p>
+          <a:p>
+            <a:pPr>
+              <a:spcAft>
+                <a:spcPts val="1000"/>
+              </a:spcAft>
+            </a:pPr>
+            <a:r>
+              <a:rPr sz="1300">
+                <a:solidFill>
+                  <a:srgbClr val="111318"/>
+                </a:solidFill>
+              </a:rPr>
+              <a:t>■  sessions par statut, points distribués</a:t>
+            </a:r>
+          </a:p>
+          <a:p>
+            <a:pPr>
+              <a:spcAft>
+                <a:spcPts val="1000"/>
+              </a:spcAft>
+            </a:pPr>
+            <a:r>
+              <a:rPr sz="1300">
+                <a:solidFill>
+                  <a:srgbClr val="111318"/>
+                </a:solidFill>
+              </a:rPr>
+              <a:t>■  Graphique des inscriptions sur 14 jours</a:t>
+            </a:r>
+          </a:p>
+          <a:p>
+            <a:pPr>
+              <a:spcAft>
+                <a:spcPts val="1000"/>
+              </a:spcAft>
+            </a:pPr>
+            <a:r>
+              <a:rPr sz="1300">
+                <a:solidFill>
+                  <a:srgbClr val="111318"/>
+                </a:solidFill>
+              </a:rPr>
+              <a:t>■  Dernières entrées du journal d'audit</a:t>
+            </a:r>
+          </a:p>
+        </p:txBody>
+      </p:sp>
+      <p:sp>
+        <p:nvSpPr>
+          <p:cNvPr id="12" name="TextBox 11"/>
+          <p:cNvSpPr txBox="1"/>
+          <p:nvPr/>
+        </p:nvSpPr>
+        <p:spPr>
+          <a:xfrm>
+            <a:off x="6309360" y="1828800"/>
+            <a:ext cx="5303520" cy="365760"/>
+          </a:xfrm>
+          <a:prstGeom prst="rect">
+            <a:avLst/>
+          </a:prstGeom>
+          <a:noFill/>
+        </p:spPr>
+        <p:txBody>
+          <a:bodyPr wrap="square">
+            <a:spAutoFit/>
+          </a:bodyPr>
+          <a:lstStyle/>
+          <a:p>
+            <a:pPr algn="l"/>
+            <a:r>
+              <a:rPr sz="1500" b="1">
+                <a:solidFill>
+                  <a:srgbClr val="111318"/>
+                </a:solidFill>
+              </a:rPr>
+              <a:t>GESTION (CRUD COMPLET)</a:t>
+            </a:r>
+          </a:p>
+        </p:txBody>
+      </p:sp>
+      <p:sp>
+        <p:nvSpPr>
+          <p:cNvPr id="13" name="TextBox 12"/>
+          <p:cNvSpPr txBox="1"/>
+          <p:nvPr/>
+        </p:nvSpPr>
+        <p:spPr>
+          <a:xfrm>
+            <a:off x="6309360" y="2240280"/>
+            <a:ext cx="5303520" cy="3657600"/>
+          </a:xfrm>
+          <a:prstGeom prst="rect">
+            <a:avLst/>
+          </a:prstGeom>
+          <a:noFill/>
+        </p:spPr>
+        <p:txBody>
+          <a:bodyPr wrap="square">
+            <a:spAutoFit/>
+          </a:bodyPr>
+          <a:lstStyle/>
+          <a:p>
+            <a:pPr>
+              <a:spcAft>
+                <a:spcPts val="1000"/>
+              </a:spcAft>
+            </a:pPr>
+            <a:r>
+              <a:rPr sz="1300">
+                <a:solidFill>
+                  <a:srgbClr val="111318"/>
+                </a:solidFill>
+              </a:rPr>
+              <a:t>■  Utilisateurs : rôle, points, suppression</a:t>
+            </a:r>
+          </a:p>
+          <a:p>
+            <a:pPr>
+              <a:spcAft>
+                <a:spcPts val="1000"/>
+              </a:spcAft>
+            </a:pPr>
+            <a:r>
+              <a:rPr sz="1300">
+                <a:solidFill>
+                  <a:srgbClr val="111318"/>
+                </a:solidFill>
+              </a:rPr>
+              <a:t>■  Compétences, matchs, sessions</a:t>
+            </a:r>
+          </a:p>
+          <a:p>
+            <a:pPr>
+              <a:spcAft>
+                <a:spcPts val="1000"/>
+              </a:spcAft>
+            </a:pPr>
+            <a:r>
+              <a:rPr sz="1300">
+                <a:solidFill>
+                  <a:srgbClr val="111318"/>
+                </a:solidFill>
+              </a:rPr>
+              <a:t>■  Badges et leur attribution</a:t>
+            </a:r>
+          </a:p>
+          <a:p>
+            <a:pPr>
+              <a:spcAft>
+                <a:spcPts val="1000"/>
+              </a:spcAft>
+            </a:pPr>
+            <a:r>
+              <a:rPr sz="1300">
+                <a:solidFill>
+                  <a:srgbClr val="111318"/>
+                </a:solidFill>
+              </a:rPr>
+              <a:t>■  Articles de la base de connaissances</a:t>
+            </a:r>
+          </a:p>
+          <a:p>
+            <a:pPr>
+              <a:spcAft>
+                <a:spcPts val="1000"/>
+              </a:spcAft>
+            </a:pPr>
+            <a:r>
+              <a:rPr sz="1300">
+                <a:solidFill>
+                  <a:srgbClr val="111318"/>
+                </a:solidFill>
+              </a:rPr>
+              <a:t>■  Ajustements manuels de points</a:t>
+            </a:r>
+          </a:p>
+          <a:p>
+            <a:pPr>
+              <a:spcAft>
+                <a:spcPts val="1000"/>
+              </a:spcAft>
+            </a:pPr>
+            <a:r>
+              <a:rPr sz="1300">
+                <a:solidFill>
+                  <a:srgbClr val="111318"/>
+                </a:solidFill>
+              </a:rPr>
+              <a:t>■  Journal d'audit (lecture seule)</a:t>
             </a:r>
           </a:p>
         </p:txBody>

</xml_diff>